<commit_message>
Adaugare teste la nivel de conditie + circuite independente
</commit_message>
<xml_diff>
--- a/PrezentareProiect.pptx
+++ b/PrezentareProiect.pptx
@@ -2,12 +2,13 @@
 <file path=ppt/presentation.xml><?xml version="1.0" encoding="utf-8"?>
 <p:presentation xmlns:a="http://schemas.openxmlformats.org/drawingml/2006/main" xmlns:r="http://schemas.openxmlformats.org/officeDocument/2006/relationships" xmlns:p="http://schemas.openxmlformats.org/presentationml/2006/main" saveSubsetFonts="1">
   <p:sldMasterIdLst>
-    <p:sldMasterId id="2147483689" r:id="rId1"/>
+    <p:sldMasterId id="2147483701" r:id="rId1"/>
   </p:sldMasterIdLst>
   <p:sldIdLst>
     <p:sldId id="256" r:id="rId2"/>
     <p:sldId id="257" r:id="rId3"/>
     <p:sldId id="258" r:id="rId4"/>
+    <p:sldId id="259" r:id="rId5"/>
   </p:sldIdLst>
   <p:sldSz cx="12192000" cy="6858000"/>
   <p:notesSz cx="6858000" cy="9144000"/>
@@ -15,7 +16,7 @@
     <a:defPPr>
       <a:defRPr lang="en-US"/>
     </a:defPPr>
-    <a:lvl1pPr marL="0" algn="l" defTabSz="457200" rtl="0" eaLnBrk="1" latinLnBrk="0" hangingPunct="1">
+    <a:lvl1pPr marL="0" algn="l" defTabSz="914400" rtl="0" eaLnBrk="1" latinLnBrk="0" hangingPunct="1">
       <a:defRPr sz="1800" kern="1200">
         <a:solidFill>
           <a:schemeClr val="tx1"/>
@@ -25,7 +26,7 @@
         <a:cs typeface="+mn-cs"/>
       </a:defRPr>
     </a:lvl1pPr>
-    <a:lvl2pPr marL="457200" algn="l" defTabSz="457200" rtl="0" eaLnBrk="1" latinLnBrk="0" hangingPunct="1">
+    <a:lvl2pPr marL="457200" algn="l" defTabSz="914400" rtl="0" eaLnBrk="1" latinLnBrk="0" hangingPunct="1">
       <a:defRPr sz="1800" kern="1200">
         <a:solidFill>
           <a:schemeClr val="tx1"/>
@@ -35,7 +36,7 @@
         <a:cs typeface="+mn-cs"/>
       </a:defRPr>
     </a:lvl2pPr>
-    <a:lvl3pPr marL="914400" algn="l" defTabSz="457200" rtl="0" eaLnBrk="1" latinLnBrk="0" hangingPunct="1">
+    <a:lvl3pPr marL="914400" algn="l" defTabSz="914400" rtl="0" eaLnBrk="1" latinLnBrk="0" hangingPunct="1">
       <a:defRPr sz="1800" kern="1200">
         <a:solidFill>
           <a:schemeClr val="tx1"/>
@@ -45,7 +46,7 @@
         <a:cs typeface="+mn-cs"/>
       </a:defRPr>
     </a:lvl3pPr>
-    <a:lvl4pPr marL="1371600" algn="l" defTabSz="457200" rtl="0" eaLnBrk="1" latinLnBrk="0" hangingPunct="1">
+    <a:lvl4pPr marL="1371600" algn="l" defTabSz="914400" rtl="0" eaLnBrk="1" latinLnBrk="0" hangingPunct="1">
       <a:defRPr sz="1800" kern="1200">
         <a:solidFill>
           <a:schemeClr val="tx1"/>
@@ -55,7 +56,7 @@
         <a:cs typeface="+mn-cs"/>
       </a:defRPr>
     </a:lvl4pPr>
-    <a:lvl5pPr marL="1828800" algn="l" defTabSz="457200" rtl="0" eaLnBrk="1" latinLnBrk="0" hangingPunct="1">
+    <a:lvl5pPr marL="1828800" algn="l" defTabSz="914400" rtl="0" eaLnBrk="1" latinLnBrk="0" hangingPunct="1">
       <a:defRPr sz="1800" kern="1200">
         <a:solidFill>
           <a:schemeClr val="tx1"/>
@@ -65,7 +66,7 @@
         <a:cs typeface="+mn-cs"/>
       </a:defRPr>
     </a:lvl5pPr>
-    <a:lvl6pPr marL="2286000" algn="l" defTabSz="457200" rtl="0" eaLnBrk="1" latinLnBrk="0" hangingPunct="1">
+    <a:lvl6pPr marL="2286000" algn="l" defTabSz="914400" rtl="0" eaLnBrk="1" latinLnBrk="0" hangingPunct="1">
       <a:defRPr sz="1800" kern="1200">
         <a:solidFill>
           <a:schemeClr val="tx1"/>
@@ -75,7 +76,7 @@
         <a:cs typeface="+mn-cs"/>
       </a:defRPr>
     </a:lvl6pPr>
-    <a:lvl7pPr marL="2743200" algn="l" defTabSz="457200" rtl="0" eaLnBrk="1" latinLnBrk="0" hangingPunct="1">
+    <a:lvl7pPr marL="2743200" algn="l" defTabSz="914400" rtl="0" eaLnBrk="1" latinLnBrk="0" hangingPunct="1">
       <a:defRPr sz="1800" kern="1200">
         <a:solidFill>
           <a:schemeClr val="tx1"/>
@@ -85,7 +86,7 @@
         <a:cs typeface="+mn-cs"/>
       </a:defRPr>
     </a:lvl7pPr>
-    <a:lvl8pPr marL="3200400" algn="l" defTabSz="457200" rtl="0" eaLnBrk="1" latinLnBrk="0" hangingPunct="1">
+    <a:lvl8pPr marL="3200400" algn="l" defTabSz="914400" rtl="0" eaLnBrk="1" latinLnBrk="0" hangingPunct="1">
       <a:defRPr sz="1800" kern="1200">
         <a:solidFill>
           <a:schemeClr val="tx1"/>
@@ -95,7 +96,7 @@
         <a:cs typeface="+mn-cs"/>
       </a:defRPr>
     </a:lvl8pPr>
-    <a:lvl9pPr marL="3657600" algn="l" defTabSz="457200" rtl="0" eaLnBrk="1" latinLnBrk="0" hangingPunct="1">
+    <a:lvl9pPr marL="3657600" algn="l" defTabSz="914400" rtl="0" eaLnBrk="1" latinLnBrk="0" hangingPunct="1">
       <a:defRPr sz="1800" kern="1200">
         <a:solidFill>
           <a:schemeClr val="tx1"/>
@@ -133,7 +134,13 @@
       </p:grpSpPr>
       <p:sp>
         <p:nvSpPr>
-          <p:cNvPr id="2" name="Title 1"/>
+          <p:cNvPr id="2" name="Title 1">
+            <a:extLst>
+              <a:ext uri="{FF2B5EF4-FFF2-40B4-BE49-F238E27FC236}">
+                <a16:creationId xmlns:a16="http://schemas.microsoft.com/office/drawing/2014/main" id="{6754ED63-783A-F085-7DF1-C4CDC97E1C55}"/>
+              </a:ext>
+            </a:extLst>
+          </p:cNvPr>
           <p:cNvSpPr>
             <a:spLocks noGrp="1"/>
           </p:cNvSpPr>
@@ -156,16 +163,21 @@
           </a:lstStyle>
           <a:p>
             <a:r>
-              <a:rPr lang="en-US"/>
+              <a:rPr lang="en-GB"/>
               <a:t>Click to edit Master title style</a:t>
             </a:r>
-            <a:endParaRPr lang="en-US" dirty="0"/>
-          </a:p>
-        </p:txBody>
-      </p:sp>
-      <p:sp>
-        <p:nvSpPr>
-          <p:cNvPr id="3" name="Subtitle 2"/>
+          </a:p>
+        </p:txBody>
+      </p:sp>
+      <p:sp>
+        <p:nvSpPr>
+          <p:cNvPr id="3" name="Subtitle 2">
+            <a:extLst>
+              <a:ext uri="{FF2B5EF4-FFF2-40B4-BE49-F238E27FC236}">
+                <a16:creationId xmlns:a16="http://schemas.microsoft.com/office/drawing/2014/main" id="{5B19B6EF-D965-4443-BB74-B1C183DE93D2}"/>
+              </a:ext>
+            </a:extLst>
+          </p:cNvPr>
           <p:cNvSpPr>
             <a:spLocks noGrp="1"/>
           </p:cNvSpPr>
@@ -221,16 +233,21 @@
           </a:lstStyle>
           <a:p>
             <a:r>
-              <a:rPr lang="en-US"/>
+              <a:rPr lang="en-GB"/>
               <a:t>Click to edit Master subtitle style</a:t>
             </a:r>
-            <a:endParaRPr lang="en-US" dirty="0"/>
-          </a:p>
-        </p:txBody>
-      </p:sp>
-      <p:sp>
-        <p:nvSpPr>
-          <p:cNvPr id="4" name="Date Placeholder 3"/>
+          </a:p>
+        </p:txBody>
+      </p:sp>
+      <p:sp>
+        <p:nvSpPr>
+          <p:cNvPr id="4" name="Date Placeholder 3">
+            <a:extLst>
+              <a:ext uri="{FF2B5EF4-FFF2-40B4-BE49-F238E27FC236}">
+                <a16:creationId xmlns:a16="http://schemas.microsoft.com/office/drawing/2014/main" id="{DF57DFA1-0FE1-92A0-B47B-B1F9826026DD}"/>
+              </a:ext>
+            </a:extLst>
+          </p:cNvPr>
           <p:cNvSpPr>
             <a:spLocks noGrp="1"/>
           </p:cNvSpPr>
@@ -253,7 +270,13 @@
       </p:sp>
       <p:sp>
         <p:nvSpPr>
-          <p:cNvPr id="5" name="Footer Placeholder 4"/>
+          <p:cNvPr id="5" name="Footer Placeholder 4">
+            <a:extLst>
+              <a:ext uri="{FF2B5EF4-FFF2-40B4-BE49-F238E27FC236}">
+                <a16:creationId xmlns:a16="http://schemas.microsoft.com/office/drawing/2014/main" id="{9EEAE6A0-7232-549C-AA08-2F74757D9354}"/>
+              </a:ext>
+            </a:extLst>
+          </p:cNvPr>
           <p:cNvSpPr>
             <a:spLocks noGrp="1"/>
           </p:cNvSpPr>
@@ -272,7 +295,13 @@
       </p:sp>
       <p:sp>
         <p:nvSpPr>
-          <p:cNvPr id="6" name="Slide Number Placeholder 5"/>
+          <p:cNvPr id="6" name="Slide Number Placeholder 5">
+            <a:extLst>
+              <a:ext uri="{FF2B5EF4-FFF2-40B4-BE49-F238E27FC236}">
+                <a16:creationId xmlns:a16="http://schemas.microsoft.com/office/drawing/2014/main" id="{11BC1653-B645-4A97-F1AB-74896C87B5FC}"/>
+              </a:ext>
+            </a:extLst>
+          </p:cNvPr>
           <p:cNvSpPr>
             <a:spLocks noGrp="1"/>
           </p:cNvSpPr>
@@ -296,7 +325,7 @@
     </p:spTree>
     <p:extLst>
       <p:ext uri="{BB962C8B-B14F-4D97-AF65-F5344CB8AC3E}">
-        <p14:creationId xmlns:p14="http://schemas.microsoft.com/office/powerpoint/2010/main" val="1097422040"/>
+        <p14:creationId xmlns:p14="http://schemas.microsoft.com/office/powerpoint/2010/main" val="3437081609"/>
       </p:ext>
     </p:extLst>
   </p:cSld>
@@ -325,7 +354,13 @@
       </p:grpSpPr>
       <p:sp>
         <p:nvSpPr>
-          <p:cNvPr id="2" name="Title 1"/>
+          <p:cNvPr id="2" name="Title 1">
+            <a:extLst>
+              <a:ext uri="{FF2B5EF4-FFF2-40B4-BE49-F238E27FC236}">
+                <a16:creationId xmlns:a16="http://schemas.microsoft.com/office/drawing/2014/main" id="{A517BB5D-0989-1238-631C-146044E70518}"/>
+              </a:ext>
+            </a:extLst>
+          </p:cNvPr>
           <p:cNvSpPr>
             <a:spLocks noGrp="1"/>
           </p:cNvSpPr>
@@ -339,16 +374,21 @@
           <a:lstStyle/>
           <a:p>
             <a:r>
-              <a:rPr lang="en-US"/>
+              <a:rPr lang="en-GB"/>
               <a:t>Click to edit Master title style</a:t>
             </a:r>
-            <a:endParaRPr lang="en-US" dirty="0"/>
-          </a:p>
-        </p:txBody>
-      </p:sp>
-      <p:sp>
-        <p:nvSpPr>
-          <p:cNvPr id="3" name="Vertical Text Placeholder 2"/>
+          </a:p>
+        </p:txBody>
+      </p:sp>
+      <p:sp>
+        <p:nvSpPr>
+          <p:cNvPr id="3" name="Vertical Text Placeholder 2">
+            <a:extLst>
+              <a:ext uri="{FF2B5EF4-FFF2-40B4-BE49-F238E27FC236}">
+                <a16:creationId xmlns:a16="http://schemas.microsoft.com/office/drawing/2014/main" id="{35AD9A27-7950-1ACF-FBE8-5432204678AF}"/>
+              </a:ext>
+            </a:extLst>
+          </p:cNvPr>
           <p:cNvSpPr>
             <a:spLocks noGrp="1"/>
           </p:cNvSpPr>
@@ -363,44 +403,49 @@
           <a:p>
             <a:pPr lvl="0"/>
             <a:r>
-              <a:rPr lang="en-US"/>
+              <a:rPr lang="en-GB"/>
               <a:t>Click to edit Master text styles</a:t>
             </a:r>
           </a:p>
           <a:p>
             <a:pPr lvl="1"/>
             <a:r>
-              <a:rPr lang="en-US"/>
+              <a:rPr lang="en-GB"/>
               <a:t>Second level</a:t>
             </a:r>
           </a:p>
           <a:p>
             <a:pPr lvl="2"/>
             <a:r>
-              <a:rPr lang="en-US"/>
+              <a:rPr lang="en-GB"/>
               <a:t>Third level</a:t>
             </a:r>
           </a:p>
           <a:p>
             <a:pPr lvl="3"/>
             <a:r>
-              <a:rPr lang="en-US"/>
+              <a:rPr lang="en-GB"/>
               <a:t>Fourth level</a:t>
             </a:r>
           </a:p>
           <a:p>
             <a:pPr lvl="4"/>
             <a:r>
-              <a:rPr lang="en-US"/>
+              <a:rPr lang="en-GB"/>
               <a:t>Fifth level</a:t>
             </a:r>
-            <a:endParaRPr lang="en-US" dirty="0"/>
-          </a:p>
-        </p:txBody>
-      </p:sp>
-      <p:sp>
-        <p:nvSpPr>
-          <p:cNvPr id="4" name="Date Placeholder 3"/>
+          </a:p>
+        </p:txBody>
+      </p:sp>
+      <p:sp>
+        <p:nvSpPr>
+          <p:cNvPr id="4" name="Date Placeholder 3">
+            <a:extLst>
+              <a:ext uri="{FF2B5EF4-FFF2-40B4-BE49-F238E27FC236}">
+                <a16:creationId xmlns:a16="http://schemas.microsoft.com/office/drawing/2014/main" id="{55CF57F1-FC97-83F8-47AA-CE79DBCEEEE2}"/>
+              </a:ext>
+            </a:extLst>
+          </p:cNvPr>
           <p:cNvSpPr>
             <a:spLocks noGrp="1"/>
           </p:cNvSpPr>
@@ -423,7 +468,13 @@
       </p:sp>
       <p:sp>
         <p:nvSpPr>
-          <p:cNvPr id="5" name="Footer Placeholder 4"/>
+          <p:cNvPr id="5" name="Footer Placeholder 4">
+            <a:extLst>
+              <a:ext uri="{FF2B5EF4-FFF2-40B4-BE49-F238E27FC236}">
+                <a16:creationId xmlns:a16="http://schemas.microsoft.com/office/drawing/2014/main" id="{E75CA1A9-90A1-D8EC-A192-6127FC158F9E}"/>
+              </a:ext>
+            </a:extLst>
+          </p:cNvPr>
           <p:cNvSpPr>
             <a:spLocks noGrp="1"/>
           </p:cNvSpPr>
@@ -442,7 +493,13 @@
       </p:sp>
       <p:sp>
         <p:nvSpPr>
-          <p:cNvPr id="6" name="Slide Number Placeholder 5"/>
+          <p:cNvPr id="6" name="Slide Number Placeholder 5">
+            <a:extLst>
+              <a:ext uri="{FF2B5EF4-FFF2-40B4-BE49-F238E27FC236}">
+                <a16:creationId xmlns:a16="http://schemas.microsoft.com/office/drawing/2014/main" id="{F7F9813A-1DA7-3ACC-B65B-5AF4D0D9919F}"/>
+              </a:ext>
+            </a:extLst>
+          </p:cNvPr>
           <p:cNvSpPr>
             <a:spLocks noGrp="1"/>
           </p:cNvSpPr>
@@ -466,7 +523,7 @@
     </p:spTree>
     <p:extLst>
       <p:ext uri="{BB962C8B-B14F-4D97-AF65-F5344CB8AC3E}">
-        <p14:creationId xmlns:p14="http://schemas.microsoft.com/office/powerpoint/2010/main" val="4050947042"/>
+        <p14:creationId xmlns:p14="http://schemas.microsoft.com/office/powerpoint/2010/main" val="1472130066"/>
       </p:ext>
     </p:extLst>
   </p:cSld>
@@ -495,7 +552,13 @@
       </p:grpSpPr>
       <p:sp>
         <p:nvSpPr>
-          <p:cNvPr id="2" name="Vertical Title 1"/>
+          <p:cNvPr id="2" name="Vertical Title 1">
+            <a:extLst>
+              <a:ext uri="{FF2B5EF4-FFF2-40B4-BE49-F238E27FC236}">
+                <a16:creationId xmlns:a16="http://schemas.microsoft.com/office/drawing/2014/main" id="{2963AA7D-A874-3EE5-FB2F-0ED0D6B04374}"/>
+              </a:ext>
+            </a:extLst>
+          </p:cNvPr>
           <p:cNvSpPr>
             <a:spLocks noGrp="1"/>
           </p:cNvSpPr>
@@ -514,16 +577,21 @@
           <a:lstStyle/>
           <a:p>
             <a:r>
-              <a:rPr lang="en-US"/>
+              <a:rPr lang="en-GB"/>
               <a:t>Click to edit Master title style</a:t>
             </a:r>
-            <a:endParaRPr lang="en-US" dirty="0"/>
-          </a:p>
-        </p:txBody>
-      </p:sp>
-      <p:sp>
-        <p:nvSpPr>
-          <p:cNvPr id="3" name="Vertical Text Placeholder 2"/>
+          </a:p>
+        </p:txBody>
+      </p:sp>
+      <p:sp>
+        <p:nvSpPr>
+          <p:cNvPr id="3" name="Vertical Text Placeholder 2">
+            <a:extLst>
+              <a:ext uri="{FF2B5EF4-FFF2-40B4-BE49-F238E27FC236}">
+                <a16:creationId xmlns:a16="http://schemas.microsoft.com/office/drawing/2014/main" id="{70FE223A-2F70-C1F3-C38F-FCF1E412282E}"/>
+              </a:ext>
+            </a:extLst>
+          </p:cNvPr>
           <p:cNvSpPr>
             <a:spLocks noGrp="1"/>
           </p:cNvSpPr>
@@ -543,44 +611,49 @@
           <a:p>
             <a:pPr lvl="0"/>
             <a:r>
-              <a:rPr lang="en-US"/>
+              <a:rPr lang="en-GB"/>
               <a:t>Click to edit Master text styles</a:t>
             </a:r>
           </a:p>
           <a:p>
             <a:pPr lvl="1"/>
             <a:r>
-              <a:rPr lang="en-US"/>
+              <a:rPr lang="en-GB"/>
               <a:t>Second level</a:t>
             </a:r>
           </a:p>
           <a:p>
             <a:pPr lvl="2"/>
             <a:r>
-              <a:rPr lang="en-US"/>
+              <a:rPr lang="en-GB"/>
               <a:t>Third level</a:t>
             </a:r>
           </a:p>
           <a:p>
             <a:pPr lvl="3"/>
             <a:r>
-              <a:rPr lang="en-US"/>
+              <a:rPr lang="en-GB"/>
               <a:t>Fourth level</a:t>
             </a:r>
           </a:p>
           <a:p>
             <a:pPr lvl="4"/>
             <a:r>
-              <a:rPr lang="en-US"/>
+              <a:rPr lang="en-GB"/>
               <a:t>Fifth level</a:t>
             </a:r>
-            <a:endParaRPr lang="en-US" dirty="0"/>
-          </a:p>
-        </p:txBody>
-      </p:sp>
-      <p:sp>
-        <p:nvSpPr>
-          <p:cNvPr id="4" name="Date Placeholder 3"/>
+          </a:p>
+        </p:txBody>
+      </p:sp>
+      <p:sp>
+        <p:nvSpPr>
+          <p:cNvPr id="4" name="Date Placeholder 3">
+            <a:extLst>
+              <a:ext uri="{FF2B5EF4-FFF2-40B4-BE49-F238E27FC236}">
+                <a16:creationId xmlns:a16="http://schemas.microsoft.com/office/drawing/2014/main" id="{60B20156-7026-5D0B-F8A9-9A70960C4C73}"/>
+              </a:ext>
+            </a:extLst>
+          </p:cNvPr>
           <p:cNvSpPr>
             <a:spLocks noGrp="1"/>
           </p:cNvSpPr>
@@ -603,7 +676,13 @@
       </p:sp>
       <p:sp>
         <p:nvSpPr>
-          <p:cNvPr id="5" name="Footer Placeholder 4"/>
+          <p:cNvPr id="5" name="Footer Placeholder 4">
+            <a:extLst>
+              <a:ext uri="{FF2B5EF4-FFF2-40B4-BE49-F238E27FC236}">
+                <a16:creationId xmlns:a16="http://schemas.microsoft.com/office/drawing/2014/main" id="{F39CD8A9-C999-FAF9-23EC-CE2CC7127145}"/>
+              </a:ext>
+            </a:extLst>
+          </p:cNvPr>
           <p:cNvSpPr>
             <a:spLocks noGrp="1"/>
           </p:cNvSpPr>
@@ -622,7 +701,13 @@
       </p:sp>
       <p:sp>
         <p:nvSpPr>
-          <p:cNvPr id="6" name="Slide Number Placeholder 5"/>
+          <p:cNvPr id="6" name="Slide Number Placeholder 5">
+            <a:extLst>
+              <a:ext uri="{FF2B5EF4-FFF2-40B4-BE49-F238E27FC236}">
+                <a16:creationId xmlns:a16="http://schemas.microsoft.com/office/drawing/2014/main" id="{0FE63F6C-35E8-D6D3-9052-17BEDE1D8408}"/>
+              </a:ext>
+            </a:extLst>
+          </p:cNvPr>
           <p:cNvSpPr>
             <a:spLocks noGrp="1"/>
           </p:cNvSpPr>
@@ -646,7 +731,7 @@
     </p:spTree>
     <p:extLst>
       <p:ext uri="{BB962C8B-B14F-4D97-AF65-F5344CB8AC3E}">
-        <p14:creationId xmlns:p14="http://schemas.microsoft.com/office/powerpoint/2010/main" val="3913172174"/>
+        <p14:creationId xmlns:p14="http://schemas.microsoft.com/office/powerpoint/2010/main" val="3143579850"/>
       </p:ext>
     </p:extLst>
   </p:cSld>
@@ -675,7 +760,13 @@
       </p:grpSpPr>
       <p:sp>
         <p:nvSpPr>
-          <p:cNvPr id="2" name="Title 1"/>
+          <p:cNvPr id="2" name="Title 1">
+            <a:extLst>
+              <a:ext uri="{FF2B5EF4-FFF2-40B4-BE49-F238E27FC236}">
+                <a16:creationId xmlns:a16="http://schemas.microsoft.com/office/drawing/2014/main" id="{EE0FD4D9-E6BD-3091-0757-408FBBD0AFEC}"/>
+              </a:ext>
+            </a:extLst>
+          </p:cNvPr>
           <p:cNvSpPr>
             <a:spLocks noGrp="1"/>
           </p:cNvSpPr>
@@ -689,16 +780,21 @@
           <a:lstStyle/>
           <a:p>
             <a:r>
-              <a:rPr lang="en-US"/>
+              <a:rPr lang="en-GB"/>
               <a:t>Click to edit Master title style</a:t>
             </a:r>
-            <a:endParaRPr lang="en-US" dirty="0"/>
-          </a:p>
-        </p:txBody>
-      </p:sp>
-      <p:sp>
-        <p:nvSpPr>
-          <p:cNvPr id="3" name="Content Placeholder 2"/>
+          </a:p>
+        </p:txBody>
+      </p:sp>
+      <p:sp>
+        <p:nvSpPr>
+          <p:cNvPr id="3" name="Content Placeholder 2">
+            <a:extLst>
+              <a:ext uri="{FF2B5EF4-FFF2-40B4-BE49-F238E27FC236}">
+                <a16:creationId xmlns:a16="http://schemas.microsoft.com/office/drawing/2014/main" id="{1F1D4F31-FC5B-5953-1C17-91C453B4B431}"/>
+              </a:ext>
+            </a:extLst>
+          </p:cNvPr>
           <p:cNvSpPr>
             <a:spLocks noGrp="1"/>
           </p:cNvSpPr>
@@ -713,44 +809,49 @@
           <a:p>
             <a:pPr lvl="0"/>
             <a:r>
-              <a:rPr lang="en-US"/>
+              <a:rPr lang="en-GB"/>
               <a:t>Click to edit Master text styles</a:t>
             </a:r>
           </a:p>
           <a:p>
             <a:pPr lvl="1"/>
             <a:r>
-              <a:rPr lang="en-US"/>
+              <a:rPr lang="en-GB"/>
               <a:t>Second level</a:t>
             </a:r>
           </a:p>
           <a:p>
             <a:pPr lvl="2"/>
             <a:r>
-              <a:rPr lang="en-US"/>
+              <a:rPr lang="en-GB"/>
               <a:t>Third level</a:t>
             </a:r>
           </a:p>
           <a:p>
             <a:pPr lvl="3"/>
             <a:r>
-              <a:rPr lang="en-US"/>
+              <a:rPr lang="en-GB"/>
               <a:t>Fourth level</a:t>
             </a:r>
           </a:p>
           <a:p>
             <a:pPr lvl="4"/>
             <a:r>
-              <a:rPr lang="en-US"/>
+              <a:rPr lang="en-GB"/>
               <a:t>Fifth level</a:t>
             </a:r>
-            <a:endParaRPr lang="en-US" dirty="0"/>
-          </a:p>
-        </p:txBody>
-      </p:sp>
-      <p:sp>
-        <p:nvSpPr>
-          <p:cNvPr id="4" name="Date Placeholder 3"/>
+          </a:p>
+        </p:txBody>
+      </p:sp>
+      <p:sp>
+        <p:nvSpPr>
+          <p:cNvPr id="4" name="Date Placeholder 3">
+            <a:extLst>
+              <a:ext uri="{FF2B5EF4-FFF2-40B4-BE49-F238E27FC236}">
+                <a16:creationId xmlns:a16="http://schemas.microsoft.com/office/drawing/2014/main" id="{49DD81F2-9540-E26D-422D-5649244B0915}"/>
+              </a:ext>
+            </a:extLst>
+          </p:cNvPr>
           <p:cNvSpPr>
             <a:spLocks noGrp="1"/>
           </p:cNvSpPr>
@@ -773,7 +874,13 @@
       </p:sp>
       <p:sp>
         <p:nvSpPr>
-          <p:cNvPr id="5" name="Footer Placeholder 4"/>
+          <p:cNvPr id="5" name="Footer Placeholder 4">
+            <a:extLst>
+              <a:ext uri="{FF2B5EF4-FFF2-40B4-BE49-F238E27FC236}">
+                <a16:creationId xmlns:a16="http://schemas.microsoft.com/office/drawing/2014/main" id="{62669A5C-103D-A47B-C302-25F401A5248D}"/>
+              </a:ext>
+            </a:extLst>
+          </p:cNvPr>
           <p:cNvSpPr>
             <a:spLocks noGrp="1"/>
           </p:cNvSpPr>
@@ -792,7 +899,13 @@
       </p:sp>
       <p:sp>
         <p:nvSpPr>
-          <p:cNvPr id="6" name="Slide Number Placeholder 5"/>
+          <p:cNvPr id="6" name="Slide Number Placeholder 5">
+            <a:extLst>
+              <a:ext uri="{FF2B5EF4-FFF2-40B4-BE49-F238E27FC236}">
+                <a16:creationId xmlns:a16="http://schemas.microsoft.com/office/drawing/2014/main" id="{EE29DBF8-9E6F-D32F-EF70-01CF636F54E9}"/>
+              </a:ext>
+            </a:extLst>
+          </p:cNvPr>
           <p:cNvSpPr>
             <a:spLocks noGrp="1"/>
           </p:cNvSpPr>
@@ -816,7 +929,7 @@
     </p:spTree>
     <p:extLst>
       <p:ext uri="{BB962C8B-B14F-4D97-AF65-F5344CB8AC3E}">
-        <p14:creationId xmlns:p14="http://schemas.microsoft.com/office/powerpoint/2010/main" val="2117151552"/>
+        <p14:creationId xmlns:p14="http://schemas.microsoft.com/office/powerpoint/2010/main" val="3468983821"/>
       </p:ext>
     </p:extLst>
   </p:cSld>
@@ -845,7 +958,13 @@
       </p:grpSpPr>
       <p:sp>
         <p:nvSpPr>
-          <p:cNvPr id="2" name="Title 1"/>
+          <p:cNvPr id="2" name="Title 1">
+            <a:extLst>
+              <a:ext uri="{FF2B5EF4-FFF2-40B4-BE49-F238E27FC236}">
+                <a16:creationId xmlns:a16="http://schemas.microsoft.com/office/drawing/2014/main" id="{D3E8E567-5496-861E-F89A-3C96DAA6C02E}"/>
+              </a:ext>
+            </a:extLst>
+          </p:cNvPr>
           <p:cNvSpPr>
             <a:spLocks noGrp="1"/>
           </p:cNvSpPr>
@@ -868,16 +987,21 @@
           </a:lstStyle>
           <a:p>
             <a:r>
-              <a:rPr lang="en-US"/>
+              <a:rPr lang="en-GB"/>
               <a:t>Click to edit Master title style</a:t>
             </a:r>
-            <a:endParaRPr lang="en-US" dirty="0"/>
-          </a:p>
-        </p:txBody>
-      </p:sp>
-      <p:sp>
-        <p:nvSpPr>
-          <p:cNvPr id="3" name="Text Placeholder 2"/>
+          </a:p>
+        </p:txBody>
+      </p:sp>
+      <p:sp>
+        <p:nvSpPr>
+          <p:cNvPr id="3" name="Text Placeholder 2">
+            <a:extLst>
+              <a:ext uri="{FF2B5EF4-FFF2-40B4-BE49-F238E27FC236}">
+                <a16:creationId xmlns:a16="http://schemas.microsoft.com/office/drawing/2014/main" id="{4A42BE2F-ACA1-71CB-33AF-1AB386D5B059}"/>
+              </a:ext>
+            </a:extLst>
+          </p:cNvPr>
           <p:cNvSpPr>
             <a:spLocks noGrp="1"/>
           </p:cNvSpPr>
@@ -899,7 +1023,7 @@
               <a:defRPr sz="2400">
                 <a:solidFill>
                   <a:schemeClr val="tx1">
-                    <a:tint val="75000"/>
+                    <a:tint val="82000"/>
                   </a:schemeClr>
                 </a:solidFill>
               </a:defRPr>
@@ -909,7 +1033,7 @@
               <a:defRPr sz="2000">
                 <a:solidFill>
                   <a:schemeClr val="tx1">
-                    <a:tint val="75000"/>
+                    <a:tint val="82000"/>
                   </a:schemeClr>
                 </a:solidFill>
               </a:defRPr>
@@ -919,7 +1043,7 @@
               <a:defRPr sz="1800">
                 <a:solidFill>
                   <a:schemeClr val="tx1">
-                    <a:tint val="75000"/>
+                    <a:tint val="82000"/>
                   </a:schemeClr>
                 </a:solidFill>
               </a:defRPr>
@@ -929,7 +1053,7 @@
               <a:defRPr sz="1600">
                 <a:solidFill>
                   <a:schemeClr val="tx1">
-                    <a:tint val="75000"/>
+                    <a:tint val="82000"/>
                   </a:schemeClr>
                 </a:solidFill>
               </a:defRPr>
@@ -939,7 +1063,7 @@
               <a:defRPr sz="1600">
                 <a:solidFill>
                   <a:schemeClr val="tx1">
-                    <a:tint val="75000"/>
+                    <a:tint val="82000"/>
                   </a:schemeClr>
                 </a:solidFill>
               </a:defRPr>
@@ -949,7 +1073,7 @@
               <a:defRPr sz="1600">
                 <a:solidFill>
                   <a:schemeClr val="tx1">
-                    <a:tint val="75000"/>
+                    <a:tint val="82000"/>
                   </a:schemeClr>
                 </a:solidFill>
               </a:defRPr>
@@ -959,7 +1083,7 @@
               <a:defRPr sz="1600">
                 <a:solidFill>
                   <a:schemeClr val="tx1">
-                    <a:tint val="75000"/>
+                    <a:tint val="82000"/>
                   </a:schemeClr>
                 </a:solidFill>
               </a:defRPr>
@@ -969,7 +1093,7 @@
               <a:defRPr sz="1600">
                 <a:solidFill>
                   <a:schemeClr val="tx1">
-                    <a:tint val="75000"/>
+                    <a:tint val="82000"/>
                   </a:schemeClr>
                 </a:solidFill>
               </a:defRPr>
@@ -979,7 +1103,7 @@
               <a:defRPr sz="1600">
                 <a:solidFill>
                   <a:schemeClr val="tx1">
-                    <a:tint val="75000"/>
+                    <a:tint val="82000"/>
                   </a:schemeClr>
                 </a:solidFill>
               </a:defRPr>
@@ -988,7 +1112,7 @@
           <a:p>
             <a:pPr lvl="0"/>
             <a:r>
-              <a:rPr lang="en-US"/>
+              <a:rPr lang="en-GB"/>
               <a:t>Click to edit Master text styles</a:t>
             </a:r>
           </a:p>
@@ -996,7 +1120,13 @@
       </p:sp>
       <p:sp>
         <p:nvSpPr>
-          <p:cNvPr id="4" name="Date Placeholder 3"/>
+          <p:cNvPr id="4" name="Date Placeholder 3">
+            <a:extLst>
+              <a:ext uri="{FF2B5EF4-FFF2-40B4-BE49-F238E27FC236}">
+                <a16:creationId xmlns:a16="http://schemas.microsoft.com/office/drawing/2014/main" id="{CDA22C13-9EA9-C42A-F884-3F064D22579A}"/>
+              </a:ext>
+            </a:extLst>
+          </p:cNvPr>
           <p:cNvSpPr>
             <a:spLocks noGrp="1"/>
           </p:cNvSpPr>
@@ -1019,7 +1149,13 @@
       </p:sp>
       <p:sp>
         <p:nvSpPr>
-          <p:cNvPr id="5" name="Footer Placeholder 4"/>
+          <p:cNvPr id="5" name="Footer Placeholder 4">
+            <a:extLst>
+              <a:ext uri="{FF2B5EF4-FFF2-40B4-BE49-F238E27FC236}">
+                <a16:creationId xmlns:a16="http://schemas.microsoft.com/office/drawing/2014/main" id="{35FF8DDA-5959-752C-E60F-59AA81AE2EED}"/>
+              </a:ext>
+            </a:extLst>
+          </p:cNvPr>
           <p:cNvSpPr>
             <a:spLocks noGrp="1"/>
           </p:cNvSpPr>
@@ -1038,7 +1174,13 @@
       </p:sp>
       <p:sp>
         <p:nvSpPr>
-          <p:cNvPr id="6" name="Slide Number Placeholder 5"/>
+          <p:cNvPr id="6" name="Slide Number Placeholder 5">
+            <a:extLst>
+              <a:ext uri="{FF2B5EF4-FFF2-40B4-BE49-F238E27FC236}">
+                <a16:creationId xmlns:a16="http://schemas.microsoft.com/office/drawing/2014/main" id="{79872237-FAD5-6383-73F7-5775C13D7446}"/>
+              </a:ext>
+            </a:extLst>
+          </p:cNvPr>
           <p:cNvSpPr>
             <a:spLocks noGrp="1"/>
           </p:cNvSpPr>
@@ -1062,7 +1204,7 @@
     </p:spTree>
     <p:extLst>
       <p:ext uri="{BB962C8B-B14F-4D97-AF65-F5344CB8AC3E}">
-        <p14:creationId xmlns:p14="http://schemas.microsoft.com/office/powerpoint/2010/main" val="754811152"/>
+        <p14:creationId xmlns:p14="http://schemas.microsoft.com/office/powerpoint/2010/main" val="916582826"/>
       </p:ext>
     </p:extLst>
   </p:cSld>
@@ -1091,7 +1233,13 @@
       </p:grpSpPr>
       <p:sp>
         <p:nvSpPr>
-          <p:cNvPr id="2" name="Title 1"/>
+          <p:cNvPr id="2" name="Title 1">
+            <a:extLst>
+              <a:ext uri="{FF2B5EF4-FFF2-40B4-BE49-F238E27FC236}">
+                <a16:creationId xmlns:a16="http://schemas.microsoft.com/office/drawing/2014/main" id="{D3A8F08D-8DCA-3D1C-6507-FEC7D3ABAEDA}"/>
+              </a:ext>
+            </a:extLst>
+          </p:cNvPr>
           <p:cNvSpPr>
             <a:spLocks noGrp="1"/>
           </p:cNvSpPr>
@@ -1105,16 +1253,21 @@
           <a:lstStyle/>
           <a:p>
             <a:r>
-              <a:rPr lang="en-US"/>
+              <a:rPr lang="en-GB"/>
               <a:t>Click to edit Master title style</a:t>
             </a:r>
-            <a:endParaRPr lang="en-US" dirty="0"/>
-          </a:p>
-        </p:txBody>
-      </p:sp>
-      <p:sp>
-        <p:nvSpPr>
-          <p:cNvPr id="3" name="Content Placeholder 2"/>
+          </a:p>
+        </p:txBody>
+      </p:sp>
+      <p:sp>
+        <p:nvSpPr>
+          <p:cNvPr id="3" name="Content Placeholder 2">
+            <a:extLst>
+              <a:ext uri="{FF2B5EF4-FFF2-40B4-BE49-F238E27FC236}">
+                <a16:creationId xmlns:a16="http://schemas.microsoft.com/office/drawing/2014/main" id="{58F4A55B-2F22-6E38-B7D2-EBA578A33C25}"/>
+              </a:ext>
+            </a:extLst>
+          </p:cNvPr>
           <p:cNvSpPr>
             <a:spLocks noGrp="1"/>
           </p:cNvSpPr>
@@ -1134,44 +1287,49 @@
           <a:p>
             <a:pPr lvl="0"/>
             <a:r>
-              <a:rPr lang="en-US"/>
+              <a:rPr lang="en-GB"/>
               <a:t>Click to edit Master text styles</a:t>
             </a:r>
           </a:p>
           <a:p>
             <a:pPr lvl="1"/>
             <a:r>
-              <a:rPr lang="en-US"/>
+              <a:rPr lang="en-GB"/>
               <a:t>Second level</a:t>
             </a:r>
           </a:p>
           <a:p>
             <a:pPr lvl="2"/>
             <a:r>
-              <a:rPr lang="en-US"/>
+              <a:rPr lang="en-GB"/>
               <a:t>Third level</a:t>
             </a:r>
           </a:p>
           <a:p>
             <a:pPr lvl="3"/>
             <a:r>
-              <a:rPr lang="en-US"/>
+              <a:rPr lang="en-GB"/>
               <a:t>Fourth level</a:t>
             </a:r>
           </a:p>
           <a:p>
             <a:pPr lvl="4"/>
             <a:r>
-              <a:rPr lang="en-US"/>
+              <a:rPr lang="en-GB"/>
               <a:t>Fifth level</a:t>
             </a:r>
-            <a:endParaRPr lang="en-US" dirty="0"/>
-          </a:p>
-        </p:txBody>
-      </p:sp>
-      <p:sp>
-        <p:nvSpPr>
-          <p:cNvPr id="4" name="Content Placeholder 3"/>
+          </a:p>
+        </p:txBody>
+      </p:sp>
+      <p:sp>
+        <p:nvSpPr>
+          <p:cNvPr id="4" name="Content Placeholder 3">
+            <a:extLst>
+              <a:ext uri="{FF2B5EF4-FFF2-40B4-BE49-F238E27FC236}">
+                <a16:creationId xmlns:a16="http://schemas.microsoft.com/office/drawing/2014/main" id="{FBC4E8DA-719F-2694-4705-765E017DE36E}"/>
+              </a:ext>
+            </a:extLst>
+          </p:cNvPr>
           <p:cNvSpPr>
             <a:spLocks noGrp="1"/>
           </p:cNvSpPr>
@@ -1191,44 +1349,49 @@
           <a:p>
             <a:pPr lvl="0"/>
             <a:r>
-              <a:rPr lang="en-US"/>
+              <a:rPr lang="en-GB"/>
               <a:t>Click to edit Master text styles</a:t>
             </a:r>
           </a:p>
           <a:p>
             <a:pPr lvl="1"/>
             <a:r>
-              <a:rPr lang="en-US"/>
+              <a:rPr lang="en-GB"/>
               <a:t>Second level</a:t>
             </a:r>
           </a:p>
           <a:p>
             <a:pPr lvl="2"/>
             <a:r>
-              <a:rPr lang="en-US"/>
+              <a:rPr lang="en-GB"/>
               <a:t>Third level</a:t>
             </a:r>
           </a:p>
           <a:p>
             <a:pPr lvl="3"/>
             <a:r>
-              <a:rPr lang="en-US"/>
+              <a:rPr lang="en-GB"/>
               <a:t>Fourth level</a:t>
             </a:r>
           </a:p>
           <a:p>
             <a:pPr lvl="4"/>
             <a:r>
-              <a:rPr lang="en-US"/>
+              <a:rPr lang="en-GB"/>
               <a:t>Fifth level</a:t>
             </a:r>
-            <a:endParaRPr lang="en-US" dirty="0"/>
-          </a:p>
-        </p:txBody>
-      </p:sp>
-      <p:sp>
-        <p:nvSpPr>
-          <p:cNvPr id="5" name="Date Placeholder 4"/>
+          </a:p>
+        </p:txBody>
+      </p:sp>
+      <p:sp>
+        <p:nvSpPr>
+          <p:cNvPr id="5" name="Date Placeholder 4">
+            <a:extLst>
+              <a:ext uri="{FF2B5EF4-FFF2-40B4-BE49-F238E27FC236}">
+                <a16:creationId xmlns:a16="http://schemas.microsoft.com/office/drawing/2014/main" id="{62ED1853-5B88-8131-A443-EFF47B2FF092}"/>
+              </a:ext>
+            </a:extLst>
+          </p:cNvPr>
           <p:cNvSpPr>
             <a:spLocks noGrp="1"/>
           </p:cNvSpPr>
@@ -1251,7 +1414,13 @@
       </p:sp>
       <p:sp>
         <p:nvSpPr>
-          <p:cNvPr id="6" name="Footer Placeholder 5"/>
+          <p:cNvPr id="6" name="Footer Placeholder 5">
+            <a:extLst>
+              <a:ext uri="{FF2B5EF4-FFF2-40B4-BE49-F238E27FC236}">
+                <a16:creationId xmlns:a16="http://schemas.microsoft.com/office/drawing/2014/main" id="{3C411521-95A4-63F0-E03E-1C7CF42CEA0A}"/>
+              </a:ext>
+            </a:extLst>
+          </p:cNvPr>
           <p:cNvSpPr>
             <a:spLocks noGrp="1"/>
           </p:cNvSpPr>
@@ -1270,7 +1439,13 @@
       </p:sp>
       <p:sp>
         <p:nvSpPr>
-          <p:cNvPr id="7" name="Slide Number Placeholder 6"/>
+          <p:cNvPr id="7" name="Slide Number Placeholder 6">
+            <a:extLst>
+              <a:ext uri="{FF2B5EF4-FFF2-40B4-BE49-F238E27FC236}">
+                <a16:creationId xmlns:a16="http://schemas.microsoft.com/office/drawing/2014/main" id="{1B1B3626-238F-844B-146A-B378C1BAEFAF}"/>
+              </a:ext>
+            </a:extLst>
+          </p:cNvPr>
           <p:cNvSpPr>
             <a:spLocks noGrp="1"/>
           </p:cNvSpPr>
@@ -1294,7 +1469,7 @@
     </p:spTree>
     <p:extLst>
       <p:ext uri="{BB962C8B-B14F-4D97-AF65-F5344CB8AC3E}">
-        <p14:creationId xmlns:p14="http://schemas.microsoft.com/office/powerpoint/2010/main" val="702494200"/>
+        <p14:creationId xmlns:p14="http://schemas.microsoft.com/office/powerpoint/2010/main" val="3081288166"/>
       </p:ext>
     </p:extLst>
   </p:cSld>
@@ -1323,7 +1498,13 @@
       </p:grpSpPr>
       <p:sp>
         <p:nvSpPr>
-          <p:cNvPr id="2" name="Title 1"/>
+          <p:cNvPr id="2" name="Title 1">
+            <a:extLst>
+              <a:ext uri="{FF2B5EF4-FFF2-40B4-BE49-F238E27FC236}">
+                <a16:creationId xmlns:a16="http://schemas.microsoft.com/office/drawing/2014/main" id="{853FE661-5578-35F0-2E7E-FC04DD0B2015}"/>
+              </a:ext>
+            </a:extLst>
+          </p:cNvPr>
           <p:cNvSpPr>
             <a:spLocks noGrp="1"/>
           </p:cNvSpPr>
@@ -1342,16 +1523,21 @@
           <a:lstStyle/>
           <a:p>
             <a:r>
-              <a:rPr lang="en-US"/>
+              <a:rPr lang="en-GB"/>
               <a:t>Click to edit Master title style</a:t>
             </a:r>
-            <a:endParaRPr lang="en-US" dirty="0"/>
-          </a:p>
-        </p:txBody>
-      </p:sp>
-      <p:sp>
-        <p:nvSpPr>
-          <p:cNvPr id="3" name="Text Placeholder 2"/>
+          </a:p>
+        </p:txBody>
+      </p:sp>
+      <p:sp>
+        <p:nvSpPr>
+          <p:cNvPr id="3" name="Text Placeholder 2">
+            <a:extLst>
+              <a:ext uri="{FF2B5EF4-FFF2-40B4-BE49-F238E27FC236}">
+                <a16:creationId xmlns:a16="http://schemas.microsoft.com/office/drawing/2014/main" id="{18D9B9EF-8FBD-C298-C1A0-DE16B74C4F5D}"/>
+              </a:ext>
+            </a:extLst>
+          </p:cNvPr>
           <p:cNvSpPr>
             <a:spLocks noGrp="1"/>
           </p:cNvSpPr>
@@ -1408,7 +1594,7 @@
           <a:p>
             <a:pPr lvl="0"/>
             <a:r>
-              <a:rPr lang="en-US"/>
+              <a:rPr lang="en-GB"/>
               <a:t>Click to edit Master text styles</a:t>
             </a:r>
           </a:p>
@@ -1416,7 +1602,13 @@
       </p:sp>
       <p:sp>
         <p:nvSpPr>
-          <p:cNvPr id="4" name="Content Placeholder 3"/>
+          <p:cNvPr id="4" name="Content Placeholder 3">
+            <a:extLst>
+              <a:ext uri="{FF2B5EF4-FFF2-40B4-BE49-F238E27FC236}">
+                <a16:creationId xmlns:a16="http://schemas.microsoft.com/office/drawing/2014/main" id="{C26E44E3-A41A-BCA7-ED6F-3787418C7121}"/>
+              </a:ext>
+            </a:extLst>
+          </p:cNvPr>
           <p:cNvSpPr>
             <a:spLocks noGrp="1"/>
           </p:cNvSpPr>
@@ -1436,44 +1628,49 @@
           <a:p>
             <a:pPr lvl="0"/>
             <a:r>
-              <a:rPr lang="en-US"/>
+              <a:rPr lang="en-GB"/>
               <a:t>Click to edit Master text styles</a:t>
             </a:r>
           </a:p>
           <a:p>
             <a:pPr lvl="1"/>
             <a:r>
-              <a:rPr lang="en-US"/>
+              <a:rPr lang="en-GB"/>
               <a:t>Second level</a:t>
             </a:r>
           </a:p>
           <a:p>
             <a:pPr lvl="2"/>
             <a:r>
-              <a:rPr lang="en-US"/>
+              <a:rPr lang="en-GB"/>
               <a:t>Third level</a:t>
             </a:r>
           </a:p>
           <a:p>
             <a:pPr lvl="3"/>
             <a:r>
-              <a:rPr lang="en-US"/>
+              <a:rPr lang="en-GB"/>
               <a:t>Fourth level</a:t>
             </a:r>
           </a:p>
           <a:p>
             <a:pPr lvl="4"/>
             <a:r>
-              <a:rPr lang="en-US"/>
+              <a:rPr lang="en-GB"/>
               <a:t>Fifth level</a:t>
             </a:r>
-            <a:endParaRPr lang="en-US" dirty="0"/>
-          </a:p>
-        </p:txBody>
-      </p:sp>
-      <p:sp>
-        <p:nvSpPr>
-          <p:cNvPr id="5" name="Text Placeholder 4"/>
+          </a:p>
+        </p:txBody>
+      </p:sp>
+      <p:sp>
+        <p:nvSpPr>
+          <p:cNvPr id="5" name="Text Placeholder 4">
+            <a:extLst>
+              <a:ext uri="{FF2B5EF4-FFF2-40B4-BE49-F238E27FC236}">
+                <a16:creationId xmlns:a16="http://schemas.microsoft.com/office/drawing/2014/main" id="{DA046FCA-7C72-89E6-E5DE-B6837C8B2B70}"/>
+              </a:ext>
+            </a:extLst>
+          </p:cNvPr>
           <p:cNvSpPr>
             <a:spLocks noGrp="1"/>
           </p:cNvSpPr>
@@ -1530,7 +1727,7 @@
           <a:p>
             <a:pPr lvl="0"/>
             <a:r>
-              <a:rPr lang="en-US"/>
+              <a:rPr lang="en-GB"/>
               <a:t>Click to edit Master text styles</a:t>
             </a:r>
           </a:p>
@@ -1538,7 +1735,13 @@
       </p:sp>
       <p:sp>
         <p:nvSpPr>
-          <p:cNvPr id="6" name="Content Placeholder 5"/>
+          <p:cNvPr id="6" name="Content Placeholder 5">
+            <a:extLst>
+              <a:ext uri="{FF2B5EF4-FFF2-40B4-BE49-F238E27FC236}">
+                <a16:creationId xmlns:a16="http://schemas.microsoft.com/office/drawing/2014/main" id="{476B6AB8-15B3-3EB9-DF1D-5344275A9368}"/>
+              </a:ext>
+            </a:extLst>
+          </p:cNvPr>
           <p:cNvSpPr>
             <a:spLocks noGrp="1"/>
           </p:cNvSpPr>
@@ -1558,44 +1761,49 @@
           <a:p>
             <a:pPr lvl="0"/>
             <a:r>
-              <a:rPr lang="en-US"/>
+              <a:rPr lang="en-GB"/>
               <a:t>Click to edit Master text styles</a:t>
             </a:r>
           </a:p>
           <a:p>
             <a:pPr lvl="1"/>
             <a:r>
-              <a:rPr lang="en-US"/>
+              <a:rPr lang="en-GB"/>
               <a:t>Second level</a:t>
             </a:r>
           </a:p>
           <a:p>
             <a:pPr lvl="2"/>
             <a:r>
-              <a:rPr lang="en-US"/>
+              <a:rPr lang="en-GB"/>
               <a:t>Third level</a:t>
             </a:r>
           </a:p>
           <a:p>
             <a:pPr lvl="3"/>
             <a:r>
-              <a:rPr lang="en-US"/>
+              <a:rPr lang="en-GB"/>
               <a:t>Fourth level</a:t>
             </a:r>
           </a:p>
           <a:p>
             <a:pPr lvl="4"/>
             <a:r>
-              <a:rPr lang="en-US"/>
+              <a:rPr lang="en-GB"/>
               <a:t>Fifth level</a:t>
             </a:r>
-            <a:endParaRPr lang="en-US" dirty="0"/>
-          </a:p>
-        </p:txBody>
-      </p:sp>
-      <p:sp>
-        <p:nvSpPr>
-          <p:cNvPr id="7" name="Date Placeholder 6"/>
+          </a:p>
+        </p:txBody>
+      </p:sp>
+      <p:sp>
+        <p:nvSpPr>
+          <p:cNvPr id="7" name="Date Placeholder 6">
+            <a:extLst>
+              <a:ext uri="{FF2B5EF4-FFF2-40B4-BE49-F238E27FC236}">
+                <a16:creationId xmlns:a16="http://schemas.microsoft.com/office/drawing/2014/main" id="{16D68551-47BA-8381-278F-6C7D9F395961}"/>
+              </a:ext>
+            </a:extLst>
+          </p:cNvPr>
           <p:cNvSpPr>
             <a:spLocks noGrp="1"/>
           </p:cNvSpPr>
@@ -1618,7 +1826,13 @@
       </p:sp>
       <p:sp>
         <p:nvSpPr>
-          <p:cNvPr id="8" name="Footer Placeholder 7"/>
+          <p:cNvPr id="8" name="Footer Placeholder 7">
+            <a:extLst>
+              <a:ext uri="{FF2B5EF4-FFF2-40B4-BE49-F238E27FC236}">
+                <a16:creationId xmlns:a16="http://schemas.microsoft.com/office/drawing/2014/main" id="{CF385BA7-C53D-6419-E84C-1D439E63603F}"/>
+              </a:ext>
+            </a:extLst>
+          </p:cNvPr>
           <p:cNvSpPr>
             <a:spLocks noGrp="1"/>
           </p:cNvSpPr>
@@ -1637,7 +1851,13 @@
       </p:sp>
       <p:sp>
         <p:nvSpPr>
-          <p:cNvPr id="9" name="Slide Number Placeholder 8"/>
+          <p:cNvPr id="9" name="Slide Number Placeholder 8">
+            <a:extLst>
+              <a:ext uri="{FF2B5EF4-FFF2-40B4-BE49-F238E27FC236}">
+                <a16:creationId xmlns:a16="http://schemas.microsoft.com/office/drawing/2014/main" id="{174CEE36-7393-B38A-36CC-7915954674B7}"/>
+              </a:ext>
+            </a:extLst>
+          </p:cNvPr>
           <p:cNvSpPr>
             <a:spLocks noGrp="1"/>
           </p:cNvSpPr>
@@ -1661,7 +1881,7 @@
     </p:spTree>
     <p:extLst>
       <p:ext uri="{BB962C8B-B14F-4D97-AF65-F5344CB8AC3E}">
-        <p14:creationId xmlns:p14="http://schemas.microsoft.com/office/powerpoint/2010/main" val="1776217487"/>
+        <p14:creationId xmlns:p14="http://schemas.microsoft.com/office/powerpoint/2010/main" val="1885321764"/>
       </p:ext>
     </p:extLst>
   </p:cSld>
@@ -1690,7 +1910,13 @@
       </p:grpSpPr>
       <p:sp>
         <p:nvSpPr>
-          <p:cNvPr id="2" name="Title 1"/>
+          <p:cNvPr id="2" name="Title 1">
+            <a:extLst>
+              <a:ext uri="{FF2B5EF4-FFF2-40B4-BE49-F238E27FC236}">
+                <a16:creationId xmlns:a16="http://schemas.microsoft.com/office/drawing/2014/main" id="{49956F84-0D66-D707-6A82-37B5882CE2EC}"/>
+              </a:ext>
+            </a:extLst>
+          </p:cNvPr>
           <p:cNvSpPr>
             <a:spLocks noGrp="1"/>
           </p:cNvSpPr>
@@ -1704,16 +1930,21 @@
           <a:lstStyle/>
           <a:p>
             <a:r>
-              <a:rPr lang="en-US"/>
+              <a:rPr lang="en-GB"/>
               <a:t>Click to edit Master title style</a:t>
             </a:r>
-            <a:endParaRPr lang="en-US" dirty="0"/>
-          </a:p>
-        </p:txBody>
-      </p:sp>
-      <p:sp>
-        <p:nvSpPr>
-          <p:cNvPr id="3" name="Date Placeholder 2"/>
+          </a:p>
+        </p:txBody>
+      </p:sp>
+      <p:sp>
+        <p:nvSpPr>
+          <p:cNvPr id="3" name="Date Placeholder 2">
+            <a:extLst>
+              <a:ext uri="{FF2B5EF4-FFF2-40B4-BE49-F238E27FC236}">
+                <a16:creationId xmlns:a16="http://schemas.microsoft.com/office/drawing/2014/main" id="{7E03D038-2571-6F2D-FE04-7888F104DA1A}"/>
+              </a:ext>
+            </a:extLst>
+          </p:cNvPr>
           <p:cNvSpPr>
             <a:spLocks noGrp="1"/>
           </p:cNvSpPr>
@@ -1736,7 +1967,13 @@
       </p:sp>
       <p:sp>
         <p:nvSpPr>
-          <p:cNvPr id="4" name="Footer Placeholder 3"/>
+          <p:cNvPr id="4" name="Footer Placeholder 3">
+            <a:extLst>
+              <a:ext uri="{FF2B5EF4-FFF2-40B4-BE49-F238E27FC236}">
+                <a16:creationId xmlns:a16="http://schemas.microsoft.com/office/drawing/2014/main" id="{DB7B2863-9C9C-25D4-2913-F3DFF024E496}"/>
+              </a:ext>
+            </a:extLst>
+          </p:cNvPr>
           <p:cNvSpPr>
             <a:spLocks noGrp="1"/>
           </p:cNvSpPr>
@@ -1755,7 +1992,13 @@
       </p:sp>
       <p:sp>
         <p:nvSpPr>
-          <p:cNvPr id="5" name="Slide Number Placeholder 4"/>
+          <p:cNvPr id="5" name="Slide Number Placeholder 4">
+            <a:extLst>
+              <a:ext uri="{FF2B5EF4-FFF2-40B4-BE49-F238E27FC236}">
+                <a16:creationId xmlns:a16="http://schemas.microsoft.com/office/drawing/2014/main" id="{70F14F1D-DC4D-EFB2-1D2C-56D2136EEA93}"/>
+              </a:ext>
+            </a:extLst>
+          </p:cNvPr>
           <p:cNvSpPr>
             <a:spLocks noGrp="1"/>
           </p:cNvSpPr>
@@ -1779,7 +2022,7 @@
     </p:spTree>
     <p:extLst>
       <p:ext uri="{BB962C8B-B14F-4D97-AF65-F5344CB8AC3E}">
-        <p14:creationId xmlns:p14="http://schemas.microsoft.com/office/powerpoint/2010/main" val="3682903306"/>
+        <p14:creationId xmlns:p14="http://schemas.microsoft.com/office/powerpoint/2010/main" val="190751331"/>
       </p:ext>
     </p:extLst>
   </p:cSld>
@@ -1808,7 +2051,13 @@
       </p:grpSpPr>
       <p:sp>
         <p:nvSpPr>
-          <p:cNvPr id="2" name="Date Placeholder 1"/>
+          <p:cNvPr id="2" name="Date Placeholder 1">
+            <a:extLst>
+              <a:ext uri="{FF2B5EF4-FFF2-40B4-BE49-F238E27FC236}">
+                <a16:creationId xmlns:a16="http://schemas.microsoft.com/office/drawing/2014/main" id="{4260F177-C7B1-DE38-D076-A1CDEA3F9114}"/>
+              </a:ext>
+            </a:extLst>
+          </p:cNvPr>
           <p:cNvSpPr>
             <a:spLocks noGrp="1"/>
           </p:cNvSpPr>
@@ -1831,7 +2080,13 @@
       </p:sp>
       <p:sp>
         <p:nvSpPr>
-          <p:cNvPr id="3" name="Footer Placeholder 2"/>
+          <p:cNvPr id="3" name="Footer Placeholder 2">
+            <a:extLst>
+              <a:ext uri="{FF2B5EF4-FFF2-40B4-BE49-F238E27FC236}">
+                <a16:creationId xmlns:a16="http://schemas.microsoft.com/office/drawing/2014/main" id="{7E8AF2E4-0368-ABBA-185E-51B6499F75DC}"/>
+              </a:ext>
+            </a:extLst>
+          </p:cNvPr>
           <p:cNvSpPr>
             <a:spLocks noGrp="1"/>
           </p:cNvSpPr>
@@ -1850,7 +2105,13 @@
       </p:sp>
       <p:sp>
         <p:nvSpPr>
-          <p:cNvPr id="4" name="Slide Number Placeholder 3"/>
+          <p:cNvPr id="4" name="Slide Number Placeholder 3">
+            <a:extLst>
+              <a:ext uri="{FF2B5EF4-FFF2-40B4-BE49-F238E27FC236}">
+                <a16:creationId xmlns:a16="http://schemas.microsoft.com/office/drawing/2014/main" id="{796C7D51-C52B-5B0A-A748-D004A922655D}"/>
+              </a:ext>
+            </a:extLst>
+          </p:cNvPr>
           <p:cNvSpPr>
             <a:spLocks noGrp="1"/>
           </p:cNvSpPr>
@@ -1874,7 +2135,7 @@
     </p:spTree>
     <p:extLst>
       <p:ext uri="{BB962C8B-B14F-4D97-AF65-F5344CB8AC3E}">
-        <p14:creationId xmlns:p14="http://schemas.microsoft.com/office/powerpoint/2010/main" val="1406131122"/>
+        <p14:creationId xmlns:p14="http://schemas.microsoft.com/office/powerpoint/2010/main" val="2871153886"/>
       </p:ext>
     </p:extLst>
   </p:cSld>
@@ -1903,7 +2164,13 @@
       </p:grpSpPr>
       <p:sp>
         <p:nvSpPr>
-          <p:cNvPr id="2" name="Title 1"/>
+          <p:cNvPr id="2" name="Title 1">
+            <a:extLst>
+              <a:ext uri="{FF2B5EF4-FFF2-40B4-BE49-F238E27FC236}">
+                <a16:creationId xmlns:a16="http://schemas.microsoft.com/office/drawing/2014/main" id="{BA89ABFE-2F39-8C89-18C3-248F582C0240}"/>
+              </a:ext>
+            </a:extLst>
+          </p:cNvPr>
           <p:cNvSpPr>
             <a:spLocks noGrp="1"/>
           </p:cNvSpPr>
@@ -1926,16 +2193,21 @@
           </a:lstStyle>
           <a:p>
             <a:r>
-              <a:rPr lang="en-US"/>
+              <a:rPr lang="en-GB"/>
               <a:t>Click to edit Master title style</a:t>
             </a:r>
-            <a:endParaRPr lang="en-US" dirty="0"/>
-          </a:p>
-        </p:txBody>
-      </p:sp>
-      <p:sp>
-        <p:nvSpPr>
-          <p:cNvPr id="3" name="Content Placeholder 2"/>
+          </a:p>
+        </p:txBody>
+      </p:sp>
+      <p:sp>
+        <p:nvSpPr>
+          <p:cNvPr id="3" name="Content Placeholder 2">
+            <a:extLst>
+              <a:ext uri="{FF2B5EF4-FFF2-40B4-BE49-F238E27FC236}">
+                <a16:creationId xmlns:a16="http://schemas.microsoft.com/office/drawing/2014/main" id="{6D1D539B-A707-CABA-9BF7-AAC32A108082}"/>
+              </a:ext>
+            </a:extLst>
+          </p:cNvPr>
           <p:cNvSpPr>
             <a:spLocks noGrp="1"/>
           </p:cNvSpPr>
@@ -1983,44 +2255,49 @@
           <a:p>
             <a:pPr lvl="0"/>
             <a:r>
-              <a:rPr lang="en-US"/>
+              <a:rPr lang="en-GB"/>
               <a:t>Click to edit Master text styles</a:t>
             </a:r>
           </a:p>
           <a:p>
             <a:pPr lvl="1"/>
             <a:r>
-              <a:rPr lang="en-US"/>
+              <a:rPr lang="en-GB"/>
               <a:t>Second level</a:t>
             </a:r>
           </a:p>
           <a:p>
             <a:pPr lvl="2"/>
             <a:r>
-              <a:rPr lang="en-US"/>
+              <a:rPr lang="en-GB"/>
               <a:t>Third level</a:t>
             </a:r>
           </a:p>
           <a:p>
             <a:pPr lvl="3"/>
             <a:r>
-              <a:rPr lang="en-US"/>
+              <a:rPr lang="en-GB"/>
               <a:t>Fourth level</a:t>
             </a:r>
           </a:p>
           <a:p>
             <a:pPr lvl="4"/>
             <a:r>
-              <a:rPr lang="en-US"/>
+              <a:rPr lang="en-GB"/>
               <a:t>Fifth level</a:t>
             </a:r>
-            <a:endParaRPr lang="en-US" dirty="0"/>
-          </a:p>
-        </p:txBody>
-      </p:sp>
-      <p:sp>
-        <p:nvSpPr>
-          <p:cNvPr id="4" name="Text Placeholder 3"/>
+          </a:p>
+        </p:txBody>
+      </p:sp>
+      <p:sp>
+        <p:nvSpPr>
+          <p:cNvPr id="4" name="Text Placeholder 3">
+            <a:extLst>
+              <a:ext uri="{FF2B5EF4-FFF2-40B4-BE49-F238E27FC236}">
+                <a16:creationId xmlns:a16="http://schemas.microsoft.com/office/drawing/2014/main" id="{9539F263-5517-989A-DF9F-E44700C329D3}"/>
+              </a:ext>
+            </a:extLst>
+          </p:cNvPr>
           <p:cNvSpPr>
             <a:spLocks noGrp="1"/>
           </p:cNvSpPr>
@@ -2077,7 +2354,7 @@
           <a:p>
             <a:pPr lvl="0"/>
             <a:r>
-              <a:rPr lang="en-US"/>
+              <a:rPr lang="en-GB"/>
               <a:t>Click to edit Master text styles</a:t>
             </a:r>
           </a:p>
@@ -2085,7 +2362,13 @@
       </p:sp>
       <p:sp>
         <p:nvSpPr>
-          <p:cNvPr id="5" name="Date Placeholder 4"/>
+          <p:cNvPr id="5" name="Date Placeholder 4">
+            <a:extLst>
+              <a:ext uri="{FF2B5EF4-FFF2-40B4-BE49-F238E27FC236}">
+                <a16:creationId xmlns:a16="http://schemas.microsoft.com/office/drawing/2014/main" id="{23B6F652-4047-661D-EE89-BF6AEBB1946F}"/>
+              </a:ext>
+            </a:extLst>
+          </p:cNvPr>
           <p:cNvSpPr>
             <a:spLocks noGrp="1"/>
           </p:cNvSpPr>
@@ -2108,7 +2391,13 @@
       </p:sp>
       <p:sp>
         <p:nvSpPr>
-          <p:cNvPr id="6" name="Footer Placeholder 5"/>
+          <p:cNvPr id="6" name="Footer Placeholder 5">
+            <a:extLst>
+              <a:ext uri="{FF2B5EF4-FFF2-40B4-BE49-F238E27FC236}">
+                <a16:creationId xmlns:a16="http://schemas.microsoft.com/office/drawing/2014/main" id="{454D9C9F-B875-AC3E-EC85-CEB72F7C3FA3}"/>
+              </a:ext>
+            </a:extLst>
+          </p:cNvPr>
           <p:cNvSpPr>
             <a:spLocks noGrp="1"/>
           </p:cNvSpPr>
@@ -2127,7 +2416,13 @@
       </p:sp>
       <p:sp>
         <p:nvSpPr>
-          <p:cNvPr id="7" name="Slide Number Placeholder 6"/>
+          <p:cNvPr id="7" name="Slide Number Placeholder 6">
+            <a:extLst>
+              <a:ext uri="{FF2B5EF4-FFF2-40B4-BE49-F238E27FC236}">
+                <a16:creationId xmlns:a16="http://schemas.microsoft.com/office/drawing/2014/main" id="{E88470B8-7F2B-B983-A74D-019E4AD26941}"/>
+              </a:ext>
+            </a:extLst>
+          </p:cNvPr>
           <p:cNvSpPr>
             <a:spLocks noGrp="1"/>
           </p:cNvSpPr>
@@ -2151,7 +2446,7 @@
     </p:spTree>
     <p:extLst>
       <p:ext uri="{BB962C8B-B14F-4D97-AF65-F5344CB8AC3E}">
-        <p14:creationId xmlns:p14="http://schemas.microsoft.com/office/powerpoint/2010/main" val="3247263916"/>
+        <p14:creationId xmlns:p14="http://schemas.microsoft.com/office/powerpoint/2010/main" val="3126027929"/>
       </p:ext>
     </p:extLst>
   </p:cSld>
@@ -2180,7 +2475,13 @@
       </p:grpSpPr>
       <p:sp>
         <p:nvSpPr>
-          <p:cNvPr id="2" name="Title 1"/>
+          <p:cNvPr id="2" name="Title 1">
+            <a:extLst>
+              <a:ext uri="{FF2B5EF4-FFF2-40B4-BE49-F238E27FC236}">
+                <a16:creationId xmlns:a16="http://schemas.microsoft.com/office/drawing/2014/main" id="{064EF6CA-16BF-095D-A6CD-B50AFA34D467}"/>
+              </a:ext>
+            </a:extLst>
+          </p:cNvPr>
           <p:cNvSpPr>
             <a:spLocks noGrp="1"/>
           </p:cNvSpPr>
@@ -2203,18 +2504,23 @@
           </a:lstStyle>
           <a:p>
             <a:r>
-              <a:rPr lang="en-US"/>
+              <a:rPr lang="en-GB"/>
               <a:t>Click to edit Master title style</a:t>
             </a:r>
-            <a:endParaRPr lang="en-US" dirty="0"/>
-          </a:p>
-        </p:txBody>
-      </p:sp>
-      <p:sp>
-        <p:nvSpPr>
-          <p:cNvPr id="3" name="Picture Placeholder 2"/>
-          <p:cNvSpPr>
-            <a:spLocks noGrp="1" noChangeAspect="1"/>
+          </a:p>
+        </p:txBody>
+      </p:sp>
+      <p:sp>
+        <p:nvSpPr>
+          <p:cNvPr id="3" name="Picture Placeholder 2">
+            <a:extLst>
+              <a:ext uri="{FF2B5EF4-FFF2-40B4-BE49-F238E27FC236}">
+                <a16:creationId xmlns:a16="http://schemas.microsoft.com/office/drawing/2014/main" id="{3968DA1A-0232-A298-840C-D188CC35F777}"/>
+              </a:ext>
+            </a:extLst>
+          </p:cNvPr>
+          <p:cNvSpPr>
+            <a:spLocks noGrp="1"/>
           </p:cNvSpPr>
           <p:nvPr>
             <p:ph type="pic" idx="1"/>
@@ -2227,7 +2533,7 @@
           </a:xfrm>
         </p:spPr>
         <p:txBody>
-          <a:bodyPr anchor="t"/>
+          <a:bodyPr/>
           <a:lstStyle>
             <a:lvl1pPr marL="0" indent="0">
               <a:buNone/>
@@ -2267,17 +2573,19 @@
             </a:lvl9pPr>
           </a:lstStyle>
           <a:p>
-            <a:r>
-              <a:rPr lang="en-US"/>
-              <a:t>Click icon to add picture</a:t>
-            </a:r>
-            <a:endParaRPr lang="en-US" dirty="0"/>
-          </a:p>
-        </p:txBody>
-      </p:sp>
-      <p:sp>
-        <p:nvSpPr>
-          <p:cNvPr id="4" name="Text Placeholder 3"/>
+            <a:endParaRPr lang="en-GB"/>
+          </a:p>
+        </p:txBody>
+      </p:sp>
+      <p:sp>
+        <p:nvSpPr>
+          <p:cNvPr id="4" name="Text Placeholder 3">
+            <a:extLst>
+              <a:ext uri="{FF2B5EF4-FFF2-40B4-BE49-F238E27FC236}">
+                <a16:creationId xmlns:a16="http://schemas.microsoft.com/office/drawing/2014/main" id="{364B65F8-E4E6-CD5C-18E1-A5DCFDBF5806}"/>
+              </a:ext>
+            </a:extLst>
+          </p:cNvPr>
           <p:cNvSpPr>
             <a:spLocks noGrp="1"/>
           </p:cNvSpPr>
@@ -2334,7 +2642,7 @@
           <a:p>
             <a:pPr lvl="0"/>
             <a:r>
-              <a:rPr lang="en-US"/>
+              <a:rPr lang="en-GB"/>
               <a:t>Click to edit Master text styles</a:t>
             </a:r>
           </a:p>
@@ -2342,7 +2650,13 @@
       </p:sp>
       <p:sp>
         <p:nvSpPr>
-          <p:cNvPr id="5" name="Date Placeholder 4"/>
+          <p:cNvPr id="5" name="Date Placeholder 4">
+            <a:extLst>
+              <a:ext uri="{FF2B5EF4-FFF2-40B4-BE49-F238E27FC236}">
+                <a16:creationId xmlns:a16="http://schemas.microsoft.com/office/drawing/2014/main" id="{B7790493-42B0-1208-5F3D-BA2E84A7079C}"/>
+              </a:ext>
+            </a:extLst>
+          </p:cNvPr>
           <p:cNvSpPr>
             <a:spLocks noGrp="1"/>
           </p:cNvSpPr>
@@ -2365,7 +2679,13 @@
       </p:sp>
       <p:sp>
         <p:nvSpPr>
-          <p:cNvPr id="6" name="Footer Placeholder 5"/>
+          <p:cNvPr id="6" name="Footer Placeholder 5">
+            <a:extLst>
+              <a:ext uri="{FF2B5EF4-FFF2-40B4-BE49-F238E27FC236}">
+                <a16:creationId xmlns:a16="http://schemas.microsoft.com/office/drawing/2014/main" id="{05A98B6B-162A-FEF0-7562-E27DA29031C3}"/>
+              </a:ext>
+            </a:extLst>
+          </p:cNvPr>
           <p:cNvSpPr>
             <a:spLocks noGrp="1"/>
           </p:cNvSpPr>
@@ -2384,7 +2704,13 @@
       </p:sp>
       <p:sp>
         <p:nvSpPr>
-          <p:cNvPr id="7" name="Slide Number Placeholder 6"/>
+          <p:cNvPr id="7" name="Slide Number Placeholder 6">
+            <a:extLst>
+              <a:ext uri="{FF2B5EF4-FFF2-40B4-BE49-F238E27FC236}">
+                <a16:creationId xmlns:a16="http://schemas.microsoft.com/office/drawing/2014/main" id="{45E09532-4884-45D8-F073-12477B9DE5DB}"/>
+              </a:ext>
+            </a:extLst>
+          </p:cNvPr>
           <p:cNvSpPr>
             <a:spLocks noGrp="1"/>
           </p:cNvSpPr>
@@ -2408,7 +2734,7 @@
     </p:spTree>
     <p:extLst>
       <p:ext uri="{BB962C8B-B14F-4D97-AF65-F5344CB8AC3E}">
-        <p14:creationId xmlns:p14="http://schemas.microsoft.com/office/powerpoint/2010/main" val="795799757"/>
+        <p14:creationId xmlns:p14="http://schemas.microsoft.com/office/powerpoint/2010/main" val="1468582822"/>
       </p:ext>
     </p:extLst>
   </p:cSld>
@@ -2442,7 +2768,13 @@
       </p:grpSpPr>
       <p:sp>
         <p:nvSpPr>
-          <p:cNvPr id="2" name="Title Placeholder 1"/>
+          <p:cNvPr id="2" name="Title Placeholder 1">
+            <a:extLst>
+              <a:ext uri="{FF2B5EF4-FFF2-40B4-BE49-F238E27FC236}">
+                <a16:creationId xmlns:a16="http://schemas.microsoft.com/office/drawing/2014/main" id="{473F1477-CDB4-6098-7F5E-FE423BC20FB6}"/>
+              </a:ext>
+            </a:extLst>
+          </p:cNvPr>
           <p:cNvSpPr>
             <a:spLocks noGrp="1"/>
           </p:cNvSpPr>
@@ -2466,16 +2798,21 @@
           <a:lstStyle/>
           <a:p>
             <a:r>
-              <a:rPr lang="en-US"/>
+              <a:rPr lang="en-GB"/>
               <a:t>Click to edit Master title style</a:t>
             </a:r>
-            <a:endParaRPr lang="en-US" dirty="0"/>
-          </a:p>
-        </p:txBody>
-      </p:sp>
-      <p:sp>
-        <p:nvSpPr>
-          <p:cNvPr id="3" name="Text Placeholder 2"/>
+          </a:p>
+        </p:txBody>
+      </p:sp>
+      <p:sp>
+        <p:nvSpPr>
+          <p:cNvPr id="3" name="Text Placeholder 2">
+            <a:extLst>
+              <a:ext uri="{FF2B5EF4-FFF2-40B4-BE49-F238E27FC236}">
+                <a16:creationId xmlns:a16="http://schemas.microsoft.com/office/drawing/2014/main" id="{420D4817-AF36-A0D2-F89B-FC3EC99FC314}"/>
+              </a:ext>
+            </a:extLst>
+          </p:cNvPr>
           <p:cNvSpPr>
             <a:spLocks noGrp="1"/>
           </p:cNvSpPr>
@@ -2500,44 +2837,49 @@
           <a:p>
             <a:pPr lvl="0"/>
             <a:r>
-              <a:rPr lang="en-US"/>
+              <a:rPr lang="en-GB"/>
               <a:t>Click to edit Master text styles</a:t>
             </a:r>
           </a:p>
           <a:p>
             <a:pPr lvl="1"/>
             <a:r>
-              <a:rPr lang="en-US"/>
+              <a:rPr lang="en-GB"/>
               <a:t>Second level</a:t>
             </a:r>
           </a:p>
           <a:p>
             <a:pPr lvl="2"/>
             <a:r>
-              <a:rPr lang="en-US"/>
+              <a:rPr lang="en-GB"/>
               <a:t>Third level</a:t>
             </a:r>
           </a:p>
           <a:p>
             <a:pPr lvl="3"/>
             <a:r>
-              <a:rPr lang="en-US"/>
+              <a:rPr lang="en-GB"/>
               <a:t>Fourth level</a:t>
             </a:r>
           </a:p>
           <a:p>
             <a:pPr lvl="4"/>
             <a:r>
-              <a:rPr lang="en-US"/>
+              <a:rPr lang="en-GB"/>
               <a:t>Fifth level</a:t>
             </a:r>
-            <a:endParaRPr lang="en-US" dirty="0"/>
-          </a:p>
-        </p:txBody>
-      </p:sp>
-      <p:sp>
-        <p:nvSpPr>
-          <p:cNvPr id="4" name="Date Placeholder 3"/>
+          </a:p>
+        </p:txBody>
+      </p:sp>
+      <p:sp>
+        <p:nvSpPr>
+          <p:cNvPr id="4" name="Date Placeholder 3">
+            <a:extLst>
+              <a:ext uri="{FF2B5EF4-FFF2-40B4-BE49-F238E27FC236}">
+                <a16:creationId xmlns:a16="http://schemas.microsoft.com/office/drawing/2014/main" id="{F3E22AC6-3499-409B-6F23-39E6B9B339C5}"/>
+              </a:ext>
+            </a:extLst>
+          </p:cNvPr>
           <p:cNvSpPr>
             <a:spLocks noGrp="1"/>
           </p:cNvSpPr>
@@ -2561,7 +2903,7 @@
               <a:defRPr sz="1200">
                 <a:solidFill>
                   <a:schemeClr val="tx1">
-                    <a:tint val="75000"/>
+                    <a:tint val="82000"/>
                   </a:schemeClr>
                 </a:solidFill>
               </a:defRPr>
@@ -2578,7 +2920,13 @@
       </p:sp>
       <p:sp>
         <p:nvSpPr>
-          <p:cNvPr id="5" name="Footer Placeholder 4"/>
+          <p:cNvPr id="5" name="Footer Placeholder 4">
+            <a:extLst>
+              <a:ext uri="{FF2B5EF4-FFF2-40B4-BE49-F238E27FC236}">
+                <a16:creationId xmlns:a16="http://schemas.microsoft.com/office/drawing/2014/main" id="{E4A35DCB-067F-1285-B0D0-7F54B9AE0425}"/>
+              </a:ext>
+            </a:extLst>
+          </p:cNvPr>
           <p:cNvSpPr>
             <a:spLocks noGrp="1"/>
           </p:cNvSpPr>
@@ -2602,7 +2950,7 @@
               <a:defRPr sz="1200">
                 <a:solidFill>
                   <a:schemeClr val="tx1">
-                    <a:tint val="75000"/>
+                    <a:tint val="82000"/>
                   </a:schemeClr>
                 </a:solidFill>
               </a:defRPr>
@@ -2615,7 +2963,13 @@
       </p:sp>
       <p:sp>
         <p:nvSpPr>
-          <p:cNvPr id="6" name="Slide Number Placeholder 5"/>
+          <p:cNvPr id="6" name="Slide Number Placeholder 5">
+            <a:extLst>
+              <a:ext uri="{FF2B5EF4-FFF2-40B4-BE49-F238E27FC236}">
+                <a16:creationId xmlns:a16="http://schemas.microsoft.com/office/drawing/2014/main" id="{60BDAAD1-06F5-1B5E-EF96-ABB1F6827C62}"/>
+              </a:ext>
+            </a:extLst>
+          </p:cNvPr>
           <p:cNvSpPr>
             <a:spLocks noGrp="1"/>
           </p:cNvSpPr>
@@ -2639,7 +2993,7 @@
               <a:defRPr sz="1200">
                 <a:solidFill>
                   <a:schemeClr val="tx1">
-                    <a:tint val="75000"/>
+                    <a:tint val="82000"/>
                   </a:schemeClr>
                 </a:solidFill>
               </a:defRPr>
@@ -2657,23 +3011,23 @@
     </p:spTree>
     <p:extLst>
       <p:ext uri="{BB962C8B-B14F-4D97-AF65-F5344CB8AC3E}">
-        <p14:creationId xmlns:p14="http://schemas.microsoft.com/office/powerpoint/2010/main" val="2396101536"/>
+        <p14:creationId xmlns:p14="http://schemas.microsoft.com/office/powerpoint/2010/main" val="3887982573"/>
       </p:ext>
     </p:extLst>
   </p:cSld>
   <p:clrMap bg1="lt1" tx1="dk1" bg2="lt2" tx2="dk2" accent1="accent1" accent2="accent2" accent3="accent3" accent4="accent4" accent5="accent5" accent6="accent6" hlink="hlink" folHlink="folHlink"/>
   <p:sldLayoutIdLst>
-    <p:sldLayoutId id="2147483690" r:id="rId1"/>
-    <p:sldLayoutId id="2147483691" r:id="rId2"/>
-    <p:sldLayoutId id="2147483692" r:id="rId3"/>
-    <p:sldLayoutId id="2147483693" r:id="rId4"/>
-    <p:sldLayoutId id="2147483694" r:id="rId5"/>
-    <p:sldLayoutId id="2147483695" r:id="rId6"/>
-    <p:sldLayoutId id="2147483696" r:id="rId7"/>
-    <p:sldLayoutId id="2147483697" r:id="rId8"/>
-    <p:sldLayoutId id="2147483698" r:id="rId9"/>
-    <p:sldLayoutId id="2147483699" r:id="rId10"/>
-    <p:sldLayoutId id="2147483700" r:id="rId11"/>
+    <p:sldLayoutId id="2147483702" r:id="rId1"/>
+    <p:sldLayoutId id="2147483703" r:id="rId2"/>
+    <p:sldLayoutId id="2147483704" r:id="rId3"/>
+    <p:sldLayoutId id="2147483705" r:id="rId4"/>
+    <p:sldLayoutId id="2147483706" r:id="rId5"/>
+    <p:sldLayoutId id="2147483707" r:id="rId6"/>
+    <p:sldLayoutId id="2147483708" r:id="rId7"/>
+    <p:sldLayoutId id="2147483709" r:id="rId8"/>
+    <p:sldLayoutId id="2147483710" r:id="rId9"/>
+    <p:sldLayoutId id="2147483711" r:id="rId10"/>
+    <p:sldLayoutId id="2147483712" r:id="rId11"/>
   </p:sldLayoutIdLst>
   <p:txStyles>
     <p:titleStyle>
@@ -3621,7 +3975,7 @@
         </p:spPr>
         <p:txBody>
           <a:bodyPr>
-            <a:normAutofit fontScale="92500" lnSpcReduction="10000"/>
+            <a:normAutofit fontScale="92500" lnSpcReduction="20000"/>
           </a:bodyPr>
           <a:lstStyle/>
           <a:p>
@@ -3722,7 +4076,7 @@
         </p:spPr>
         <p:txBody>
           <a:bodyPr>
-            <a:normAutofit fontScale="92500" lnSpcReduction="10000"/>
+            <a:normAutofit fontScale="92500" lnSpcReduction="20000"/>
           </a:bodyPr>
           <a:lstStyle/>
           <a:p>
@@ -4067,10 +4421,1348 @@
 </p:sld>
 </file>
 
+<file path=ppt/slides/slide4.xml><?xml version="1.0" encoding="utf-8"?>
+<p:sld xmlns:a="http://schemas.openxmlformats.org/drawingml/2006/main" xmlns:r="http://schemas.openxmlformats.org/officeDocument/2006/relationships" xmlns:p="http://schemas.openxmlformats.org/presentationml/2006/main">
+  <p:cSld>
+    <p:bg>
+      <p:bgPr>
+        <a:solidFill>
+          <a:schemeClr val="bg1"/>
+        </a:solidFill>
+        <a:effectLst/>
+      </p:bgPr>
+    </p:bg>
+    <p:spTree>
+      <p:nvGrpSpPr>
+        <p:cNvPr id="1" name=""/>
+        <p:cNvGrpSpPr/>
+        <p:nvPr/>
+      </p:nvGrpSpPr>
+      <p:grpSpPr>
+        <a:xfrm>
+          <a:off x="0" y="0"/>
+          <a:ext cx="0" cy="0"/>
+          <a:chOff x="0" y="0"/>
+          <a:chExt cx="0" cy="0"/>
+        </a:xfrm>
+      </p:grpSpPr>
+      <p:sp>
+        <p:nvSpPr>
+          <p:cNvPr id="2" name="Title 1">
+            <a:extLst>
+              <a:ext uri="{FF2B5EF4-FFF2-40B4-BE49-F238E27FC236}">
+                <a16:creationId xmlns:a16="http://schemas.microsoft.com/office/drawing/2014/main" id="{5EF3E4D2-5C84-0C61-4BD2-F346711016CB}"/>
+              </a:ext>
+            </a:extLst>
+          </p:cNvPr>
+          <p:cNvSpPr>
+            <a:spLocks noGrp="1"/>
+          </p:cNvSpPr>
+          <p:nvPr>
+            <p:ph type="title"/>
+          </p:nvPr>
+        </p:nvSpPr>
+        <p:spPr>
+          <a:xfrm>
+            <a:off x="1193800" y="3165044"/>
+            <a:ext cx="10317480" cy="3542045"/>
+          </a:xfrm>
+        </p:spPr>
+        <p:txBody>
+          <a:bodyPr vert="horz" lIns="91440" tIns="45720" rIns="91440" bIns="45720" rtlCol="0" anchor="b">
+            <a:normAutofit fontScale="90000"/>
+          </a:bodyPr>
+          <a:lstStyle/>
+          <a:p>
+            <a:r>
+              <a:rPr lang="en-US" sz="4000" kern="1200" dirty="0">
+                <a:solidFill>
+                  <a:schemeClr val="tx1"/>
+                </a:solidFill>
+                <a:latin typeface="+mj-lt"/>
+                <a:ea typeface="+mj-ea"/>
+                <a:cs typeface="+mj-cs"/>
+              </a:rPr>
+              <a:t>Analiza la </a:t>
+            </a:r>
+            <a:r>
+              <a:rPr lang="en-US" sz="4000" kern="1200" dirty="0" err="1">
+                <a:solidFill>
+                  <a:schemeClr val="tx1"/>
+                </a:solidFill>
+                <a:latin typeface="+mj-lt"/>
+                <a:ea typeface="+mj-ea"/>
+                <a:cs typeface="+mj-cs"/>
+              </a:rPr>
+              <a:t>nivel</a:t>
+            </a:r>
+            <a:r>
+              <a:rPr lang="en-US" sz="4000" kern="1200" dirty="0">
+                <a:solidFill>
+                  <a:schemeClr val="tx1"/>
+                </a:solidFill>
+                <a:latin typeface="+mj-lt"/>
+                <a:ea typeface="+mj-ea"/>
+                <a:cs typeface="+mj-cs"/>
+              </a:rPr>
+              <a:t> de </a:t>
+            </a:r>
+            <a:r>
+              <a:rPr lang="en-US" sz="4000" kern="1200" dirty="0" err="1">
+                <a:solidFill>
+                  <a:schemeClr val="tx1"/>
+                </a:solidFill>
+                <a:latin typeface="+mj-lt"/>
+                <a:ea typeface="+mj-ea"/>
+                <a:cs typeface="+mj-cs"/>
+              </a:rPr>
+              <a:t>conditie</a:t>
+            </a:r>
+            <a:r>
+              <a:rPr lang="en-US" sz="4000" kern="1200" dirty="0">
+                <a:solidFill>
+                  <a:schemeClr val="tx1"/>
+                </a:solidFill>
+                <a:latin typeface="+mj-lt"/>
+                <a:ea typeface="+mj-ea"/>
+                <a:cs typeface="+mj-cs"/>
+              </a:rPr>
+              <a:t> + </a:t>
+            </a:r>
+            <a:r>
+              <a:rPr lang="en-US" sz="4000" kern="1200" dirty="0" err="1">
+                <a:solidFill>
+                  <a:schemeClr val="tx1"/>
+                </a:solidFill>
+                <a:latin typeface="+mj-lt"/>
+                <a:ea typeface="+mj-ea"/>
+                <a:cs typeface="+mj-cs"/>
+              </a:rPr>
+              <a:t>Circuite</a:t>
+            </a:r>
+            <a:r>
+              <a:rPr lang="en-US" sz="4000" kern="1200" dirty="0">
+                <a:solidFill>
+                  <a:schemeClr val="tx1"/>
+                </a:solidFill>
+                <a:latin typeface="+mj-lt"/>
+                <a:ea typeface="+mj-ea"/>
+                <a:cs typeface="+mj-cs"/>
+              </a:rPr>
+              <a:t> </a:t>
+            </a:r>
+            <a:r>
+              <a:rPr lang="en-US" sz="4000" kern="1200" dirty="0" err="1">
+                <a:solidFill>
+                  <a:schemeClr val="tx1"/>
+                </a:solidFill>
+                <a:latin typeface="+mj-lt"/>
+                <a:ea typeface="+mj-ea"/>
+                <a:cs typeface="+mj-cs"/>
+              </a:rPr>
+              <a:t>independente</a:t>
+            </a:r>
+            <a:br>
+              <a:rPr lang="en-US" sz="2900" kern="1200" dirty="0">
+                <a:solidFill>
+                  <a:schemeClr val="tx1"/>
+                </a:solidFill>
+                <a:latin typeface="+mj-lt"/>
+                <a:ea typeface="+mj-ea"/>
+                <a:cs typeface="+mj-cs"/>
+              </a:rPr>
+            </a:br>
+            <a:br>
+              <a:rPr lang="en-US" sz="2900" kern="1200" dirty="0">
+                <a:solidFill>
+                  <a:schemeClr val="tx1"/>
+                </a:solidFill>
+                <a:latin typeface="+mj-lt"/>
+                <a:ea typeface="+mj-ea"/>
+                <a:cs typeface="+mj-cs"/>
+              </a:rPr>
+            </a:br>
+            <a:r>
+              <a:rPr lang="en-US" sz="2900" b="1" kern="1200" dirty="0" err="1">
+                <a:solidFill>
+                  <a:schemeClr val="tx1"/>
+                </a:solidFill>
+                <a:latin typeface="+mj-lt"/>
+                <a:ea typeface="+mj-ea"/>
+                <a:cs typeface="+mj-cs"/>
+              </a:rPr>
+              <a:t>Obiectiv</a:t>
+            </a:r>
+            <a:r>
+              <a:rPr lang="en-US" sz="2900" b="1" kern="1200" dirty="0">
+                <a:solidFill>
+                  <a:schemeClr val="tx1"/>
+                </a:solidFill>
+                <a:latin typeface="+mj-lt"/>
+                <a:ea typeface="+mj-ea"/>
+                <a:cs typeface="+mj-cs"/>
+              </a:rPr>
+              <a:t>:</a:t>
+            </a:r>
+            <a:br>
+              <a:rPr lang="en-US" sz="2900" kern="1200" dirty="0">
+                <a:solidFill>
+                  <a:schemeClr val="tx1"/>
+                </a:solidFill>
+                <a:latin typeface="+mj-lt"/>
+                <a:ea typeface="+mj-ea"/>
+                <a:cs typeface="+mj-cs"/>
+              </a:rPr>
+            </a:br>
+            <a:r>
+              <a:rPr lang="en-US" sz="2900" kern="1200" dirty="0">
+                <a:solidFill>
+                  <a:schemeClr val="tx1"/>
+                </a:solidFill>
+                <a:latin typeface="+mj-lt"/>
+                <a:ea typeface="+mj-ea"/>
+                <a:cs typeface="+mj-cs"/>
+              </a:rPr>
+              <a:t>- </a:t>
+            </a:r>
+            <a:r>
+              <a:rPr lang="en-US" sz="2900" kern="1200" dirty="0" err="1">
+                <a:solidFill>
+                  <a:schemeClr val="tx1"/>
+                </a:solidFill>
+                <a:latin typeface="+mj-lt"/>
+                <a:ea typeface="+mj-ea"/>
+                <a:cs typeface="+mj-cs"/>
+              </a:rPr>
+              <a:t>acoperire</a:t>
+            </a:r>
+            <a:r>
+              <a:rPr lang="en-US" sz="2900" kern="1200" dirty="0">
+                <a:solidFill>
+                  <a:schemeClr val="tx1"/>
+                </a:solidFill>
+                <a:latin typeface="+mj-lt"/>
+                <a:ea typeface="+mj-ea"/>
+                <a:cs typeface="+mj-cs"/>
+              </a:rPr>
+              <a:t> la </a:t>
+            </a:r>
+            <a:r>
+              <a:rPr lang="en-US" sz="2900" kern="1200" dirty="0" err="1">
+                <a:solidFill>
+                  <a:schemeClr val="tx1"/>
+                </a:solidFill>
+                <a:latin typeface="+mj-lt"/>
+                <a:ea typeface="+mj-ea"/>
+                <a:cs typeface="+mj-cs"/>
+              </a:rPr>
+              <a:t>nivel</a:t>
+            </a:r>
+            <a:r>
+              <a:rPr lang="en-US" sz="2900" kern="1200" dirty="0">
+                <a:solidFill>
+                  <a:schemeClr val="tx1"/>
+                </a:solidFill>
+                <a:latin typeface="+mj-lt"/>
+                <a:ea typeface="+mj-ea"/>
+                <a:cs typeface="+mj-cs"/>
+              </a:rPr>
+              <a:t> de </a:t>
+            </a:r>
+            <a:r>
+              <a:rPr lang="en-US" sz="2900" kern="1200" dirty="0" err="1">
+                <a:solidFill>
+                  <a:schemeClr val="tx1"/>
+                </a:solidFill>
+                <a:latin typeface="+mj-lt"/>
+                <a:ea typeface="+mj-ea"/>
+                <a:cs typeface="+mj-cs"/>
+              </a:rPr>
+              <a:t>conditie</a:t>
+            </a:r>
+            <a:r>
+              <a:rPr lang="en-US" sz="2900" kern="1200" dirty="0">
+                <a:solidFill>
+                  <a:schemeClr val="tx1"/>
+                </a:solidFill>
+                <a:latin typeface="+mj-lt"/>
+                <a:ea typeface="+mj-ea"/>
+                <a:cs typeface="+mj-cs"/>
+              </a:rPr>
+              <a:t> </a:t>
+            </a:r>
+            <a:r>
+              <a:rPr lang="en-US" sz="2900" kern="1200" dirty="0" err="1">
+                <a:solidFill>
+                  <a:schemeClr val="tx1"/>
+                </a:solidFill>
+                <a:latin typeface="+mj-lt"/>
+                <a:ea typeface="+mj-ea"/>
+                <a:cs typeface="+mj-cs"/>
+              </a:rPr>
+              <a:t>pentru</a:t>
+            </a:r>
+            <a:r>
+              <a:rPr lang="en-US" sz="2900" kern="1200" dirty="0">
+                <a:solidFill>
+                  <a:schemeClr val="tx1"/>
+                </a:solidFill>
+                <a:latin typeface="+mj-lt"/>
+                <a:ea typeface="+mj-ea"/>
+                <a:cs typeface="+mj-cs"/>
+              </a:rPr>
+              <a:t> </a:t>
+            </a:r>
+            <a:r>
+              <a:rPr lang="en-US" sz="2900" kern="1200" dirty="0" err="1">
+                <a:solidFill>
+                  <a:schemeClr val="tx1"/>
+                </a:solidFill>
+                <a:latin typeface="+mj-lt"/>
+                <a:ea typeface="+mj-ea"/>
+                <a:cs typeface="+mj-cs"/>
+              </a:rPr>
+              <a:t>deciziile</a:t>
+            </a:r>
+            <a:r>
+              <a:rPr lang="en-US" sz="2900" kern="1200" dirty="0">
+                <a:solidFill>
+                  <a:schemeClr val="tx1"/>
+                </a:solidFill>
+                <a:latin typeface="+mj-lt"/>
+                <a:ea typeface="+mj-ea"/>
+                <a:cs typeface="+mj-cs"/>
+              </a:rPr>
+              <a:t> din </a:t>
+            </a:r>
+            <a:r>
+              <a:rPr lang="en-US" sz="2900" kern="1200" dirty="0" err="1">
+                <a:solidFill>
+                  <a:schemeClr val="tx1"/>
+                </a:solidFill>
+                <a:latin typeface="+mj-lt"/>
+                <a:ea typeface="+mj-ea"/>
+                <a:cs typeface="+mj-cs"/>
+              </a:rPr>
+              <a:t>metodele</a:t>
+            </a:r>
+            <a:r>
+              <a:rPr lang="en-US" sz="2900" kern="1200" dirty="0">
+                <a:solidFill>
+                  <a:schemeClr val="tx1"/>
+                </a:solidFill>
+                <a:latin typeface="+mj-lt"/>
+                <a:ea typeface="+mj-ea"/>
+                <a:cs typeface="+mj-cs"/>
+              </a:rPr>
+              <a:t>: </a:t>
+            </a:r>
+            <a:r>
+              <a:rPr lang="en-US" sz="2900" kern="1200" dirty="0" err="1">
+                <a:solidFill>
+                  <a:schemeClr val="tx1"/>
+                </a:solidFill>
+                <a:latin typeface="+mj-lt"/>
+                <a:ea typeface="+mj-ea"/>
+                <a:cs typeface="+mj-cs"/>
+              </a:rPr>
+              <a:t>is_valid</a:t>
+            </a:r>
+            <a:r>
+              <a:rPr lang="en-US" sz="2900" kern="1200" dirty="0">
+                <a:solidFill>
+                  <a:schemeClr val="tx1"/>
+                </a:solidFill>
+                <a:latin typeface="+mj-lt"/>
+                <a:ea typeface="+mj-ea"/>
+                <a:cs typeface="+mj-cs"/>
+              </a:rPr>
+              <a:t>, </a:t>
+            </a:r>
+            <a:r>
+              <a:rPr lang="en-US" sz="2900" kern="1200" dirty="0" err="1">
+                <a:solidFill>
+                  <a:schemeClr val="tx1"/>
+                </a:solidFill>
+                <a:latin typeface="+mj-lt"/>
+                <a:ea typeface="+mj-ea"/>
+                <a:cs typeface="+mj-cs"/>
+              </a:rPr>
+              <a:t>trecut</a:t>
+            </a:r>
+            <a:r>
+              <a:rPr lang="en-US" sz="2900" kern="1200" dirty="0">
+                <a:solidFill>
+                  <a:schemeClr val="tx1"/>
+                </a:solidFill>
+                <a:latin typeface="+mj-lt"/>
+                <a:ea typeface="+mj-ea"/>
+                <a:cs typeface="+mj-cs"/>
+              </a:rPr>
+              <a:t>, </a:t>
+            </a:r>
+            <a:r>
+              <a:rPr lang="en-US" sz="2900" kern="1200" dirty="0" err="1">
+                <a:solidFill>
+                  <a:schemeClr val="tx1"/>
+                </a:solidFill>
+                <a:latin typeface="+mj-lt"/>
+                <a:ea typeface="+mj-ea"/>
+                <a:cs typeface="+mj-cs"/>
+              </a:rPr>
+              <a:t>eligibil_bursa</a:t>
+            </a:r>
+            <a:br>
+              <a:rPr lang="en-US" sz="2900" kern="1200" dirty="0">
+                <a:solidFill>
+                  <a:schemeClr val="tx1"/>
+                </a:solidFill>
+                <a:latin typeface="+mj-lt"/>
+                <a:ea typeface="+mj-ea"/>
+                <a:cs typeface="+mj-cs"/>
+              </a:rPr>
+            </a:br>
+            <a:r>
+              <a:rPr lang="en-US" sz="2900" kern="1200" dirty="0">
+                <a:solidFill>
+                  <a:schemeClr val="tx1"/>
+                </a:solidFill>
+                <a:latin typeface="+mj-lt"/>
+                <a:ea typeface="+mj-ea"/>
+                <a:cs typeface="+mj-cs"/>
+              </a:rPr>
+              <a:t>- </a:t>
+            </a:r>
+            <a:r>
+              <a:rPr lang="en-US" sz="2900" kern="1200" dirty="0" err="1">
+                <a:solidFill>
+                  <a:schemeClr val="tx1"/>
+                </a:solidFill>
+                <a:latin typeface="+mj-lt"/>
+                <a:ea typeface="+mj-ea"/>
+                <a:cs typeface="+mj-cs"/>
+              </a:rPr>
+              <a:t>acoperire</a:t>
+            </a:r>
+            <a:r>
+              <a:rPr lang="en-US" sz="2900" kern="1200" dirty="0">
+                <a:solidFill>
+                  <a:schemeClr val="tx1"/>
+                </a:solidFill>
+                <a:latin typeface="+mj-lt"/>
+                <a:ea typeface="+mj-ea"/>
+                <a:cs typeface="+mj-cs"/>
+              </a:rPr>
+              <a:t> pe </a:t>
+            </a:r>
+            <a:r>
+              <a:rPr lang="en-US" sz="2900" kern="1200" dirty="0" err="1">
+                <a:solidFill>
+                  <a:schemeClr val="tx1"/>
+                </a:solidFill>
+                <a:latin typeface="+mj-lt"/>
+                <a:ea typeface="+mj-ea"/>
+                <a:cs typeface="+mj-cs"/>
+              </a:rPr>
+              <a:t>circuite</a:t>
+            </a:r>
+            <a:r>
+              <a:rPr lang="en-US" sz="2900" kern="1200" dirty="0">
+                <a:solidFill>
+                  <a:schemeClr val="tx1"/>
+                </a:solidFill>
+                <a:latin typeface="+mj-lt"/>
+                <a:ea typeface="+mj-ea"/>
+                <a:cs typeface="+mj-cs"/>
+              </a:rPr>
+              <a:t> </a:t>
+            </a:r>
+            <a:r>
+              <a:rPr lang="en-US" sz="2900" kern="1200" dirty="0" err="1">
+                <a:solidFill>
+                  <a:schemeClr val="tx1"/>
+                </a:solidFill>
+                <a:latin typeface="+mj-lt"/>
+                <a:ea typeface="+mj-ea"/>
+                <a:cs typeface="+mj-cs"/>
+              </a:rPr>
+              <a:t>independente</a:t>
+            </a:r>
+            <a:r>
+              <a:rPr lang="en-US" sz="2900" kern="1200" dirty="0">
+                <a:solidFill>
+                  <a:schemeClr val="tx1"/>
+                </a:solidFill>
+                <a:latin typeface="+mj-lt"/>
+                <a:ea typeface="+mj-ea"/>
+                <a:cs typeface="+mj-cs"/>
+              </a:rPr>
+              <a:t> </a:t>
+            </a:r>
+            <a:r>
+              <a:rPr lang="en-US" sz="2900" kern="1200" dirty="0" err="1">
+                <a:solidFill>
+                  <a:schemeClr val="tx1"/>
+                </a:solidFill>
+                <a:latin typeface="+mj-lt"/>
+                <a:ea typeface="+mj-ea"/>
+                <a:cs typeface="+mj-cs"/>
+              </a:rPr>
+              <a:t>pentru</a:t>
+            </a:r>
+            <a:r>
+              <a:rPr lang="en-US" sz="2900" kern="1200" dirty="0">
+                <a:solidFill>
+                  <a:schemeClr val="tx1"/>
+                </a:solidFill>
+                <a:latin typeface="+mj-lt"/>
+                <a:ea typeface="+mj-ea"/>
+                <a:cs typeface="+mj-cs"/>
+              </a:rPr>
+              <a:t> </a:t>
+            </a:r>
+            <a:r>
+              <a:rPr lang="en-US" sz="2900" kern="1200" dirty="0" err="1">
+                <a:solidFill>
+                  <a:schemeClr val="tx1"/>
+                </a:solidFill>
+                <a:latin typeface="+mj-lt"/>
+                <a:ea typeface="+mj-ea"/>
+                <a:cs typeface="+mj-cs"/>
+              </a:rPr>
+              <a:t>fluxurile</a:t>
+            </a:r>
+            <a:r>
+              <a:rPr lang="en-US" sz="2900" kern="1200" dirty="0">
+                <a:solidFill>
+                  <a:schemeClr val="tx1"/>
+                </a:solidFill>
+                <a:latin typeface="+mj-lt"/>
+                <a:ea typeface="+mj-ea"/>
+                <a:cs typeface="+mj-cs"/>
+              </a:rPr>
+              <a:t> </a:t>
+            </a:r>
+            <a:r>
+              <a:rPr lang="en-US" sz="2900" kern="1200" dirty="0" err="1">
+                <a:solidFill>
+                  <a:schemeClr val="tx1"/>
+                </a:solidFill>
+                <a:latin typeface="+mj-lt"/>
+                <a:ea typeface="+mj-ea"/>
+                <a:cs typeface="+mj-cs"/>
+              </a:rPr>
+              <a:t>principale</a:t>
+            </a:r>
+            <a:r>
+              <a:rPr lang="en-US" sz="2900" kern="1200" dirty="0">
+                <a:solidFill>
+                  <a:schemeClr val="tx1"/>
+                </a:solidFill>
+                <a:latin typeface="+mj-lt"/>
+                <a:ea typeface="+mj-ea"/>
+                <a:cs typeface="+mj-cs"/>
+              </a:rPr>
+              <a:t> din: </a:t>
+            </a:r>
+            <a:r>
+              <a:rPr lang="en-US" sz="2900" kern="1200" dirty="0" err="1">
+                <a:solidFill>
+                  <a:schemeClr val="tx1"/>
+                </a:solidFill>
+                <a:latin typeface="+mj-lt"/>
+                <a:ea typeface="+mj-ea"/>
+                <a:cs typeface="+mj-cs"/>
+              </a:rPr>
+              <a:t>trecut</a:t>
+            </a:r>
+            <a:r>
+              <a:rPr lang="en-US" sz="2900" kern="1200" dirty="0">
+                <a:solidFill>
+                  <a:schemeClr val="tx1"/>
+                </a:solidFill>
+                <a:latin typeface="+mj-lt"/>
+                <a:ea typeface="+mj-ea"/>
+                <a:cs typeface="+mj-cs"/>
+              </a:rPr>
+              <a:t> </a:t>
+            </a:r>
+            <a:r>
+              <a:rPr lang="en-US" sz="2900" kern="1200" dirty="0" err="1">
+                <a:solidFill>
+                  <a:schemeClr val="tx1"/>
+                </a:solidFill>
+                <a:latin typeface="+mj-lt"/>
+                <a:ea typeface="+mj-ea"/>
+                <a:cs typeface="+mj-cs"/>
+              </a:rPr>
+              <a:t>si</a:t>
+            </a:r>
+            <a:r>
+              <a:rPr lang="en-US" sz="2900" kern="1200" dirty="0">
+                <a:solidFill>
+                  <a:schemeClr val="tx1"/>
+                </a:solidFill>
+                <a:latin typeface="+mj-lt"/>
+                <a:ea typeface="+mj-ea"/>
+                <a:cs typeface="+mj-cs"/>
+              </a:rPr>
+              <a:t> </a:t>
+            </a:r>
+            <a:r>
+              <a:rPr lang="en-US" sz="2900" kern="1200" dirty="0" err="1">
+                <a:solidFill>
+                  <a:schemeClr val="tx1"/>
+                </a:solidFill>
+                <a:latin typeface="+mj-lt"/>
+                <a:ea typeface="+mj-ea"/>
+                <a:cs typeface="+mj-cs"/>
+              </a:rPr>
+              <a:t>categorie_nota</a:t>
+            </a:r>
+            <a:br>
+              <a:rPr lang="en-US" sz="2900" kern="1200" dirty="0">
+                <a:solidFill>
+                  <a:schemeClr val="tx1"/>
+                </a:solidFill>
+                <a:latin typeface="+mj-lt"/>
+                <a:ea typeface="+mj-ea"/>
+                <a:cs typeface="+mj-cs"/>
+              </a:rPr>
+            </a:br>
+            <a:br>
+              <a:rPr lang="en-US" sz="2900" kern="1200" dirty="0">
+                <a:solidFill>
+                  <a:schemeClr val="tx1"/>
+                </a:solidFill>
+                <a:latin typeface="+mj-lt"/>
+                <a:ea typeface="+mj-ea"/>
+                <a:cs typeface="+mj-cs"/>
+              </a:rPr>
+            </a:br>
+            <a:r>
+              <a:rPr lang="en-US" sz="2900" b="1" kern="1200" dirty="0">
+                <a:solidFill>
+                  <a:schemeClr val="tx1"/>
+                </a:solidFill>
+                <a:latin typeface="+mj-lt"/>
+                <a:ea typeface="+mj-ea"/>
+                <a:cs typeface="+mj-cs"/>
+              </a:rPr>
+              <a:t> </a:t>
+            </a:r>
+            <a:r>
+              <a:rPr lang="en-US" sz="2900" b="1" kern="1200" dirty="0" err="1">
+                <a:solidFill>
+                  <a:schemeClr val="tx1"/>
+                </a:solidFill>
+                <a:latin typeface="+mj-lt"/>
+                <a:ea typeface="+mj-ea"/>
+                <a:cs typeface="+mj-cs"/>
+              </a:rPr>
+              <a:t>Conditii</a:t>
+            </a:r>
+            <a:r>
+              <a:rPr lang="en-US" sz="2900" b="1" kern="1200" dirty="0">
+                <a:solidFill>
+                  <a:schemeClr val="tx1"/>
+                </a:solidFill>
+                <a:latin typeface="+mj-lt"/>
+                <a:ea typeface="+mj-ea"/>
+                <a:cs typeface="+mj-cs"/>
+              </a:rPr>
+              <a:t> </a:t>
+            </a:r>
+            <a:r>
+              <a:rPr lang="en-US" sz="2900" b="1" kern="1200" dirty="0" err="1">
+                <a:solidFill>
+                  <a:schemeClr val="tx1"/>
+                </a:solidFill>
+                <a:latin typeface="+mj-lt"/>
+                <a:ea typeface="+mj-ea"/>
+                <a:cs typeface="+mj-cs"/>
+              </a:rPr>
+              <a:t>urmarite</a:t>
+            </a:r>
+            <a:r>
+              <a:rPr lang="en-US" sz="2900" b="1" kern="1200" dirty="0">
+                <a:solidFill>
+                  <a:schemeClr val="tx1"/>
+                </a:solidFill>
+                <a:latin typeface="+mj-lt"/>
+                <a:ea typeface="+mj-ea"/>
+                <a:cs typeface="+mj-cs"/>
+              </a:rPr>
+              <a:t>:</a:t>
+            </a:r>
+            <a:br>
+              <a:rPr lang="en-US" sz="2900" kern="1200" dirty="0">
+                <a:solidFill>
+                  <a:schemeClr val="tx1"/>
+                </a:solidFill>
+                <a:latin typeface="+mj-lt"/>
+                <a:ea typeface="+mj-ea"/>
+                <a:cs typeface="+mj-cs"/>
+              </a:rPr>
+            </a:br>
+            <a:r>
+              <a:rPr lang="en-US" sz="2900" kern="1200" dirty="0">
+                <a:solidFill>
+                  <a:schemeClr val="tx1"/>
+                </a:solidFill>
+                <a:latin typeface="+mj-lt"/>
+                <a:ea typeface="+mj-ea"/>
+                <a:cs typeface="+mj-cs"/>
+              </a:rPr>
+              <a:t>- </a:t>
+            </a:r>
+            <a:r>
+              <a:rPr lang="en-US" sz="2900" kern="1200" dirty="0" err="1">
+                <a:solidFill>
+                  <a:schemeClr val="tx1"/>
+                </a:solidFill>
+                <a:latin typeface="+mj-lt"/>
+                <a:ea typeface="+mj-ea"/>
+                <a:cs typeface="+mj-cs"/>
+              </a:rPr>
+              <a:t>is_valid</a:t>
+            </a:r>
+            <a:r>
+              <a:rPr lang="en-US" sz="2900" kern="1200" dirty="0">
+                <a:solidFill>
+                  <a:schemeClr val="tx1"/>
+                </a:solidFill>
+                <a:latin typeface="+mj-lt"/>
+                <a:ea typeface="+mj-ea"/>
+                <a:cs typeface="+mj-cs"/>
+              </a:rPr>
+              <a:t>: </a:t>
+            </a:r>
+            <a:r>
+              <a:rPr lang="en-US" sz="2900" kern="1200" dirty="0" err="1">
+                <a:solidFill>
+                  <a:schemeClr val="tx1"/>
+                </a:solidFill>
+                <a:latin typeface="+mj-lt"/>
+                <a:ea typeface="+mj-ea"/>
+                <a:cs typeface="+mj-cs"/>
+              </a:rPr>
+              <a:t>fiecare</a:t>
+            </a:r>
+            <a:r>
+              <a:rPr lang="en-US" sz="2900" kern="1200" dirty="0">
+                <a:solidFill>
+                  <a:schemeClr val="tx1"/>
+                </a:solidFill>
+                <a:latin typeface="+mj-lt"/>
+                <a:ea typeface="+mj-ea"/>
+                <a:cs typeface="+mj-cs"/>
+              </a:rPr>
+              <a:t> </a:t>
+            </a:r>
+            <a:r>
+              <a:rPr lang="en-US" sz="2900" kern="1200" dirty="0" err="1">
+                <a:solidFill>
+                  <a:schemeClr val="tx1"/>
+                </a:solidFill>
+                <a:latin typeface="+mj-lt"/>
+                <a:ea typeface="+mj-ea"/>
+                <a:cs typeface="+mj-cs"/>
+              </a:rPr>
+              <a:t>conditie</a:t>
+            </a:r>
+            <a:r>
+              <a:rPr lang="en-US" sz="2900" kern="1200" dirty="0">
+                <a:solidFill>
+                  <a:schemeClr val="tx1"/>
+                </a:solidFill>
+                <a:latin typeface="+mj-lt"/>
+                <a:ea typeface="+mj-ea"/>
+                <a:cs typeface="+mj-cs"/>
+              </a:rPr>
+              <a:t> de forma x &lt; 0 </a:t>
+            </a:r>
+            <a:r>
+              <a:rPr lang="en-US" sz="2900" kern="1200" dirty="0" err="1">
+                <a:solidFill>
+                  <a:schemeClr val="tx1"/>
+                </a:solidFill>
+                <a:latin typeface="+mj-lt"/>
+                <a:ea typeface="+mj-ea"/>
+                <a:cs typeface="+mj-cs"/>
+              </a:rPr>
+              <a:t>sau</a:t>
+            </a:r>
+            <a:r>
+              <a:rPr lang="en-US" sz="2900" kern="1200" dirty="0">
+                <a:solidFill>
+                  <a:schemeClr val="tx1"/>
+                </a:solidFill>
+                <a:latin typeface="+mj-lt"/>
+                <a:ea typeface="+mj-ea"/>
+                <a:cs typeface="+mj-cs"/>
+              </a:rPr>
+              <a:t> x &gt; 100 </a:t>
+            </a:r>
+            <a:r>
+              <a:rPr lang="en-US" sz="2900" kern="1200" dirty="0" err="1">
+                <a:solidFill>
+                  <a:schemeClr val="tx1"/>
+                </a:solidFill>
+                <a:latin typeface="+mj-lt"/>
+                <a:ea typeface="+mj-ea"/>
+                <a:cs typeface="+mj-cs"/>
+              </a:rPr>
+              <a:t>evaluata</a:t>
+            </a:r>
+            <a:r>
+              <a:rPr lang="en-US" sz="2900" kern="1200" dirty="0">
+                <a:solidFill>
+                  <a:schemeClr val="tx1"/>
+                </a:solidFill>
+                <a:latin typeface="+mj-lt"/>
+                <a:ea typeface="+mj-ea"/>
+                <a:cs typeface="+mj-cs"/>
+              </a:rPr>
+              <a:t> pe True/False</a:t>
+            </a:r>
+            <a:br>
+              <a:rPr lang="en-US" sz="2900" kern="1200" dirty="0">
+                <a:solidFill>
+                  <a:schemeClr val="tx1"/>
+                </a:solidFill>
+                <a:latin typeface="+mj-lt"/>
+                <a:ea typeface="+mj-ea"/>
+                <a:cs typeface="+mj-cs"/>
+              </a:rPr>
+            </a:br>
+            <a:r>
+              <a:rPr lang="en-US" sz="2900" kern="1200" dirty="0">
+                <a:solidFill>
+                  <a:schemeClr val="tx1"/>
+                </a:solidFill>
+                <a:latin typeface="+mj-lt"/>
+                <a:ea typeface="+mj-ea"/>
+                <a:cs typeface="+mj-cs"/>
+              </a:rPr>
+              <a:t>- </a:t>
+            </a:r>
+            <a:r>
+              <a:rPr lang="en-US" sz="2900" kern="1200" dirty="0" err="1">
+                <a:solidFill>
+                  <a:schemeClr val="tx1"/>
+                </a:solidFill>
+                <a:latin typeface="+mj-lt"/>
+                <a:ea typeface="+mj-ea"/>
+                <a:cs typeface="+mj-cs"/>
+              </a:rPr>
+              <a:t>trecut</a:t>
+            </a:r>
+            <a:r>
+              <a:rPr lang="en-US" sz="2900" kern="1200" dirty="0">
+                <a:solidFill>
+                  <a:schemeClr val="tx1"/>
+                </a:solidFill>
+                <a:latin typeface="+mj-lt"/>
+                <a:ea typeface="+mj-ea"/>
+                <a:cs typeface="+mj-cs"/>
+              </a:rPr>
+              <a:t>: </a:t>
+            </a:r>
+            <a:r>
+              <a:rPr lang="en-US" sz="2900" kern="1200" dirty="0" err="1">
+                <a:solidFill>
+                  <a:schemeClr val="tx1"/>
+                </a:solidFill>
+                <a:latin typeface="+mj-lt"/>
+                <a:ea typeface="+mj-ea"/>
+                <a:cs typeface="+mj-cs"/>
+              </a:rPr>
+              <a:t>prezenta</a:t>
+            </a:r>
+            <a:r>
+              <a:rPr lang="en-US" sz="2900" kern="1200" dirty="0">
+                <a:solidFill>
+                  <a:schemeClr val="tx1"/>
+                </a:solidFill>
+                <a:latin typeface="+mj-lt"/>
+                <a:ea typeface="+mj-ea"/>
+                <a:cs typeface="+mj-cs"/>
+              </a:rPr>
+              <a:t> &lt; 50 </a:t>
+            </a:r>
+            <a:r>
+              <a:rPr lang="en-US" sz="2900" kern="1200" dirty="0" err="1">
+                <a:solidFill>
+                  <a:schemeClr val="tx1"/>
+                </a:solidFill>
+                <a:latin typeface="+mj-lt"/>
+                <a:ea typeface="+mj-ea"/>
+                <a:cs typeface="+mj-cs"/>
+              </a:rPr>
+              <a:t>si</a:t>
+            </a:r>
+            <a:r>
+              <a:rPr lang="en-US" sz="2900" kern="1200" dirty="0">
+                <a:solidFill>
+                  <a:schemeClr val="tx1"/>
+                </a:solidFill>
+                <a:latin typeface="+mj-lt"/>
+                <a:ea typeface="+mj-ea"/>
+                <a:cs typeface="+mj-cs"/>
+              </a:rPr>
+              <a:t> nota &gt;= 50 evaluate pe True/False</a:t>
+            </a:r>
+            <a:br>
+              <a:rPr lang="en-US" sz="2900" kern="1200" dirty="0">
+                <a:solidFill>
+                  <a:schemeClr val="tx1"/>
+                </a:solidFill>
+                <a:latin typeface="+mj-lt"/>
+                <a:ea typeface="+mj-ea"/>
+                <a:cs typeface="+mj-cs"/>
+              </a:rPr>
+            </a:br>
+            <a:r>
+              <a:rPr lang="en-US" sz="2900" kern="1200" dirty="0">
+                <a:solidFill>
+                  <a:schemeClr val="tx1"/>
+                </a:solidFill>
+                <a:latin typeface="+mj-lt"/>
+                <a:ea typeface="+mj-ea"/>
+                <a:cs typeface="+mj-cs"/>
+              </a:rPr>
+              <a:t>- </a:t>
+            </a:r>
+            <a:r>
+              <a:rPr lang="en-US" sz="2900" kern="1200" dirty="0" err="1">
+                <a:solidFill>
+                  <a:schemeClr val="tx1"/>
+                </a:solidFill>
+                <a:latin typeface="+mj-lt"/>
+                <a:ea typeface="+mj-ea"/>
+                <a:cs typeface="+mj-cs"/>
+              </a:rPr>
+              <a:t>eligibil_bursa</a:t>
+            </a:r>
+            <a:r>
+              <a:rPr lang="en-US" sz="2900" kern="1200" dirty="0">
+                <a:solidFill>
+                  <a:schemeClr val="tx1"/>
+                </a:solidFill>
+                <a:latin typeface="+mj-lt"/>
+                <a:ea typeface="+mj-ea"/>
+                <a:cs typeface="+mj-cs"/>
+              </a:rPr>
+              <a:t>: (nota &gt;= 85) </a:t>
+            </a:r>
+            <a:r>
+              <a:rPr lang="en-US" sz="2900" kern="1200" dirty="0" err="1">
+                <a:solidFill>
+                  <a:schemeClr val="tx1"/>
+                </a:solidFill>
+                <a:latin typeface="+mj-lt"/>
+                <a:ea typeface="+mj-ea"/>
+                <a:cs typeface="+mj-cs"/>
+              </a:rPr>
+              <a:t>si</a:t>
+            </a:r>
+            <a:r>
+              <a:rPr lang="en-US" sz="2900" kern="1200" dirty="0">
+                <a:solidFill>
+                  <a:schemeClr val="tx1"/>
+                </a:solidFill>
+                <a:latin typeface="+mj-lt"/>
+                <a:ea typeface="+mj-ea"/>
+                <a:cs typeface="+mj-cs"/>
+              </a:rPr>
+              <a:t> (</a:t>
+            </a:r>
+            <a:r>
+              <a:rPr lang="en-US" sz="2900" kern="1200" dirty="0" err="1">
+                <a:solidFill>
+                  <a:schemeClr val="tx1"/>
+                </a:solidFill>
+                <a:latin typeface="+mj-lt"/>
+                <a:ea typeface="+mj-ea"/>
+                <a:cs typeface="+mj-cs"/>
+              </a:rPr>
+              <a:t>prezenta</a:t>
+            </a:r>
+            <a:r>
+              <a:rPr lang="en-US" sz="2900" kern="1200" dirty="0">
+                <a:solidFill>
+                  <a:schemeClr val="tx1"/>
+                </a:solidFill>
+                <a:latin typeface="+mj-lt"/>
+                <a:ea typeface="+mj-ea"/>
+                <a:cs typeface="+mj-cs"/>
+              </a:rPr>
+              <a:t> &gt;= 80) evaluate pe True/False</a:t>
+            </a:r>
+            <a:br>
+              <a:rPr lang="en-US" sz="2900" kern="1200" dirty="0">
+                <a:solidFill>
+                  <a:schemeClr val="tx1"/>
+                </a:solidFill>
+                <a:latin typeface="+mj-lt"/>
+                <a:ea typeface="+mj-ea"/>
+                <a:cs typeface="+mj-cs"/>
+              </a:rPr>
+            </a:br>
+            <a:br>
+              <a:rPr lang="en-US" sz="2900" kern="1200" dirty="0">
+                <a:solidFill>
+                  <a:schemeClr val="tx1"/>
+                </a:solidFill>
+                <a:latin typeface="+mj-lt"/>
+                <a:ea typeface="+mj-ea"/>
+                <a:cs typeface="+mj-cs"/>
+              </a:rPr>
+            </a:br>
+            <a:r>
+              <a:rPr lang="en-US" sz="2900" b="1" kern="1200" dirty="0" err="1">
+                <a:solidFill>
+                  <a:schemeClr val="tx1"/>
+                </a:solidFill>
+                <a:latin typeface="+mj-lt"/>
+                <a:ea typeface="+mj-ea"/>
+                <a:cs typeface="+mj-cs"/>
+              </a:rPr>
+              <a:t>Circuite</a:t>
+            </a:r>
+            <a:r>
+              <a:rPr lang="en-US" sz="2900" b="1" kern="1200" dirty="0">
+                <a:solidFill>
+                  <a:schemeClr val="tx1"/>
+                </a:solidFill>
+                <a:latin typeface="+mj-lt"/>
+                <a:ea typeface="+mj-ea"/>
+                <a:cs typeface="+mj-cs"/>
+              </a:rPr>
+              <a:t> </a:t>
+            </a:r>
+            <a:r>
+              <a:rPr lang="en-US" sz="2900" b="1" kern="1200" dirty="0" err="1">
+                <a:solidFill>
+                  <a:schemeClr val="tx1"/>
+                </a:solidFill>
+                <a:latin typeface="+mj-lt"/>
+                <a:ea typeface="+mj-ea"/>
+                <a:cs typeface="+mj-cs"/>
+              </a:rPr>
+              <a:t>independente</a:t>
+            </a:r>
+            <a:r>
+              <a:rPr lang="en-US" sz="2900" b="1" kern="1200" dirty="0">
+                <a:solidFill>
+                  <a:schemeClr val="tx1"/>
+                </a:solidFill>
+                <a:latin typeface="+mj-lt"/>
+                <a:ea typeface="+mj-ea"/>
+                <a:cs typeface="+mj-cs"/>
+              </a:rPr>
+              <a:t> </a:t>
+            </a:r>
+            <a:r>
+              <a:rPr lang="en-US" sz="2900" b="1" kern="1200" dirty="0" err="1">
+                <a:solidFill>
+                  <a:schemeClr val="tx1"/>
+                </a:solidFill>
+                <a:latin typeface="+mj-lt"/>
+                <a:ea typeface="+mj-ea"/>
+                <a:cs typeface="+mj-cs"/>
+              </a:rPr>
+              <a:t>urmarite</a:t>
+            </a:r>
+            <a:r>
+              <a:rPr lang="en-US" sz="2900" b="1" kern="1200" dirty="0">
+                <a:solidFill>
+                  <a:schemeClr val="tx1"/>
+                </a:solidFill>
+                <a:latin typeface="+mj-lt"/>
+                <a:ea typeface="+mj-ea"/>
+                <a:cs typeface="+mj-cs"/>
+              </a:rPr>
+              <a:t>:</a:t>
+            </a:r>
+            <a:br>
+              <a:rPr lang="en-US" sz="2900" kern="1200" dirty="0">
+                <a:solidFill>
+                  <a:schemeClr val="tx1"/>
+                </a:solidFill>
+                <a:latin typeface="+mj-lt"/>
+                <a:ea typeface="+mj-ea"/>
+                <a:cs typeface="+mj-cs"/>
+              </a:rPr>
+            </a:br>
+            <a:r>
+              <a:rPr lang="en-US" sz="2900" kern="1200" dirty="0">
+                <a:solidFill>
+                  <a:schemeClr val="tx1"/>
+                </a:solidFill>
+                <a:latin typeface="+mj-lt"/>
+                <a:ea typeface="+mj-ea"/>
+                <a:cs typeface="+mj-cs"/>
+              </a:rPr>
+              <a:t>- </a:t>
+            </a:r>
+            <a:r>
+              <a:rPr lang="en-US" sz="2900" kern="1200" dirty="0" err="1">
+                <a:solidFill>
+                  <a:schemeClr val="tx1"/>
+                </a:solidFill>
+                <a:latin typeface="+mj-lt"/>
+                <a:ea typeface="+mj-ea"/>
+                <a:cs typeface="+mj-cs"/>
+              </a:rPr>
+              <a:t>trecut</a:t>
+            </a:r>
+            <a:r>
+              <a:rPr lang="en-US" sz="2900" kern="1200" dirty="0">
+                <a:solidFill>
+                  <a:schemeClr val="tx1"/>
+                </a:solidFill>
+                <a:latin typeface="+mj-lt"/>
+                <a:ea typeface="+mj-ea"/>
+                <a:cs typeface="+mj-cs"/>
+              </a:rPr>
+              <a:t>: invalid input, </a:t>
+            </a:r>
+            <a:r>
+              <a:rPr lang="en-US" sz="2900" kern="1200" dirty="0" err="1">
+                <a:solidFill>
+                  <a:schemeClr val="tx1"/>
+                </a:solidFill>
+                <a:latin typeface="+mj-lt"/>
+                <a:ea typeface="+mj-ea"/>
+                <a:cs typeface="+mj-cs"/>
+              </a:rPr>
+              <a:t>prezenta</a:t>
+            </a:r>
+            <a:r>
+              <a:rPr lang="en-US" sz="2900" kern="1200" dirty="0">
+                <a:solidFill>
+                  <a:schemeClr val="tx1"/>
+                </a:solidFill>
+                <a:latin typeface="+mj-lt"/>
+                <a:ea typeface="+mj-ea"/>
+                <a:cs typeface="+mj-cs"/>
+              </a:rPr>
+              <a:t> sub </a:t>
+            </a:r>
+            <a:r>
+              <a:rPr lang="en-US" sz="2900" kern="1200" dirty="0" err="1">
+                <a:solidFill>
+                  <a:schemeClr val="tx1"/>
+                </a:solidFill>
+                <a:latin typeface="+mj-lt"/>
+                <a:ea typeface="+mj-ea"/>
+                <a:cs typeface="+mj-cs"/>
+              </a:rPr>
+              <a:t>prag</a:t>
+            </a:r>
+            <a:r>
+              <a:rPr lang="en-US" sz="2900" kern="1200" dirty="0">
+                <a:solidFill>
+                  <a:schemeClr val="tx1"/>
+                </a:solidFill>
+                <a:latin typeface="+mj-lt"/>
+                <a:ea typeface="+mj-ea"/>
+                <a:cs typeface="+mj-cs"/>
+              </a:rPr>
+              <a:t>, </a:t>
+            </a:r>
+            <a:r>
+              <a:rPr lang="en-US" sz="2900" kern="1200" dirty="0" err="1">
+                <a:solidFill>
+                  <a:schemeClr val="tx1"/>
+                </a:solidFill>
+                <a:latin typeface="+mj-lt"/>
+                <a:ea typeface="+mj-ea"/>
+                <a:cs typeface="+mj-cs"/>
+              </a:rPr>
+              <a:t>trecut</a:t>
+            </a:r>
+            <a:r>
+              <a:rPr lang="en-US" sz="2900" kern="1200" dirty="0">
+                <a:solidFill>
+                  <a:schemeClr val="tx1"/>
+                </a:solidFill>
+                <a:latin typeface="+mj-lt"/>
+                <a:ea typeface="+mj-ea"/>
+                <a:cs typeface="+mj-cs"/>
+              </a:rPr>
+              <a:t>, </a:t>
+            </a:r>
+            <a:r>
+              <a:rPr lang="en-US" sz="2900" kern="1200" dirty="0" err="1">
+                <a:solidFill>
+                  <a:schemeClr val="tx1"/>
+                </a:solidFill>
+                <a:latin typeface="+mj-lt"/>
+                <a:ea typeface="+mj-ea"/>
+                <a:cs typeface="+mj-cs"/>
+              </a:rPr>
+              <a:t>picat</a:t>
+            </a:r>
+            <a:r>
+              <a:rPr lang="en-US" sz="2900" kern="1200" dirty="0">
+                <a:solidFill>
+                  <a:schemeClr val="tx1"/>
+                </a:solidFill>
+                <a:latin typeface="+mj-lt"/>
+                <a:ea typeface="+mj-ea"/>
+                <a:cs typeface="+mj-cs"/>
+              </a:rPr>
+              <a:t> din nota</a:t>
+            </a:r>
+            <a:br>
+              <a:rPr lang="en-US" sz="2900" kern="1200" dirty="0">
+                <a:solidFill>
+                  <a:schemeClr val="tx1"/>
+                </a:solidFill>
+                <a:latin typeface="+mj-lt"/>
+                <a:ea typeface="+mj-ea"/>
+                <a:cs typeface="+mj-cs"/>
+              </a:rPr>
+            </a:br>
+            <a:r>
+              <a:rPr lang="en-US" sz="2900" kern="1200" dirty="0">
+                <a:solidFill>
+                  <a:schemeClr val="tx1"/>
+                </a:solidFill>
+                <a:latin typeface="+mj-lt"/>
+                <a:ea typeface="+mj-ea"/>
+                <a:cs typeface="+mj-cs"/>
+              </a:rPr>
+              <a:t>- </a:t>
+            </a:r>
+            <a:r>
+              <a:rPr lang="en-US" sz="2900" kern="1200" dirty="0" err="1">
+                <a:solidFill>
+                  <a:schemeClr val="tx1"/>
+                </a:solidFill>
+                <a:latin typeface="+mj-lt"/>
+                <a:ea typeface="+mj-ea"/>
+                <a:cs typeface="+mj-cs"/>
+              </a:rPr>
+              <a:t>categorie_nota</a:t>
+            </a:r>
+            <a:r>
+              <a:rPr lang="en-US" sz="2900" kern="1200" dirty="0">
+                <a:solidFill>
+                  <a:schemeClr val="tx1"/>
+                </a:solidFill>
+                <a:latin typeface="+mj-lt"/>
+                <a:ea typeface="+mj-ea"/>
+                <a:cs typeface="+mj-cs"/>
+              </a:rPr>
+              <a:t>: </a:t>
+            </a:r>
+            <a:r>
+              <a:rPr lang="en-US" sz="2900" kern="1200" dirty="0" err="1">
+                <a:solidFill>
+                  <a:schemeClr val="tx1"/>
+                </a:solidFill>
+                <a:latin typeface="+mj-lt"/>
+                <a:ea typeface="+mj-ea"/>
+                <a:cs typeface="+mj-cs"/>
+              </a:rPr>
+              <a:t>Picat</a:t>
+            </a:r>
+            <a:r>
+              <a:rPr lang="en-US" sz="2900" kern="1200" dirty="0">
+                <a:solidFill>
+                  <a:schemeClr val="tx1"/>
+                </a:solidFill>
+                <a:latin typeface="+mj-lt"/>
+                <a:ea typeface="+mj-ea"/>
+                <a:cs typeface="+mj-cs"/>
+              </a:rPr>
+              <a:t>, Bine, </a:t>
+            </a:r>
+            <a:r>
+              <a:rPr lang="en-US" sz="2900" kern="1200" dirty="0" err="1">
+                <a:solidFill>
+                  <a:schemeClr val="tx1"/>
+                </a:solidFill>
+                <a:latin typeface="+mj-lt"/>
+                <a:ea typeface="+mj-ea"/>
+                <a:cs typeface="+mj-cs"/>
+              </a:rPr>
+              <a:t>Foarte</a:t>
+            </a:r>
+            <a:r>
+              <a:rPr lang="en-US" sz="2900" kern="1200" dirty="0">
+                <a:solidFill>
+                  <a:schemeClr val="tx1"/>
+                </a:solidFill>
+                <a:latin typeface="+mj-lt"/>
+                <a:ea typeface="+mj-ea"/>
+                <a:cs typeface="+mj-cs"/>
+              </a:rPr>
+              <a:t> bine, </a:t>
+            </a:r>
+            <a:r>
+              <a:rPr lang="en-US" sz="2900" kern="1200" dirty="0" err="1">
+                <a:solidFill>
+                  <a:schemeClr val="tx1"/>
+                </a:solidFill>
+                <a:latin typeface="+mj-lt"/>
+                <a:ea typeface="+mj-ea"/>
+                <a:cs typeface="+mj-cs"/>
+              </a:rPr>
+              <a:t>Excelent</a:t>
+            </a:r>
+            <a:br>
+              <a:rPr lang="en-US" sz="2900" kern="1200" dirty="0">
+                <a:solidFill>
+                  <a:schemeClr val="tx1"/>
+                </a:solidFill>
+                <a:latin typeface="+mj-lt"/>
+                <a:ea typeface="+mj-ea"/>
+                <a:cs typeface="+mj-cs"/>
+              </a:rPr>
+            </a:br>
+            <a:br>
+              <a:rPr lang="en-US" sz="2900" kern="1200" dirty="0">
+                <a:solidFill>
+                  <a:schemeClr val="tx1"/>
+                </a:solidFill>
+                <a:latin typeface="+mj-lt"/>
+                <a:ea typeface="+mj-ea"/>
+                <a:cs typeface="+mj-cs"/>
+              </a:rPr>
+            </a:br>
+            <a:endParaRPr lang="en-US" sz="2900" kern="1200" dirty="0">
+              <a:solidFill>
+                <a:schemeClr val="tx1"/>
+              </a:solidFill>
+              <a:latin typeface="+mj-lt"/>
+              <a:ea typeface="+mj-ea"/>
+              <a:cs typeface="+mj-cs"/>
+            </a:endParaRPr>
+          </a:p>
+        </p:txBody>
+      </p:sp>
+    </p:spTree>
+    <p:extLst>
+      <p:ext uri="{BB962C8B-B14F-4D97-AF65-F5344CB8AC3E}">
+        <p14:creationId xmlns:p14="http://schemas.microsoft.com/office/powerpoint/2010/main" val="1856170669"/>
+      </p:ext>
+    </p:extLst>
+  </p:cSld>
+  <p:clrMapOvr>
+    <a:masterClrMapping/>
+  </p:clrMapOvr>
+</p:sld>
+</file>
+
 <file path=ppt/theme/theme1.xml><?xml version="1.0" encoding="utf-8"?>
-<a:theme xmlns:a="http://schemas.openxmlformats.org/drawingml/2006/main" name="Office 2013 - 2022 Theme">
+<a:theme xmlns:a="http://schemas.openxmlformats.org/drawingml/2006/main" name="Office Theme">
   <a:themeElements>
-    <a:clrScheme name="Office 2013 - 2022 Theme">
+    <a:clrScheme name="Office">
       <a:dk1>
         <a:sysClr val="windowText" lastClr="000000"/>
       </a:dk1>
@@ -4078,39 +5770,39 @@
         <a:sysClr val="window" lastClr="FFFFFF"/>
       </a:lt1>
       <a:dk2>
-        <a:srgbClr val="44546A"/>
+        <a:srgbClr val="0E2841"/>
       </a:dk2>
       <a:lt2>
-        <a:srgbClr val="E7E6E6"/>
+        <a:srgbClr val="E8E8E8"/>
       </a:lt2>
       <a:accent1>
-        <a:srgbClr val="4472C4"/>
+        <a:srgbClr val="156082"/>
       </a:accent1>
       <a:accent2>
-        <a:srgbClr val="ED7D31"/>
+        <a:srgbClr val="E97132"/>
       </a:accent2>
       <a:accent3>
-        <a:srgbClr val="A5A5A5"/>
+        <a:srgbClr val="196B24"/>
       </a:accent3>
       <a:accent4>
-        <a:srgbClr val="FFC000"/>
+        <a:srgbClr val="0F9ED5"/>
       </a:accent4>
       <a:accent5>
-        <a:srgbClr val="5B9BD5"/>
+        <a:srgbClr val="A02B93"/>
       </a:accent5>
       <a:accent6>
-        <a:srgbClr val="70AD47"/>
+        <a:srgbClr val="4EA72E"/>
       </a:accent6>
       <a:hlink>
-        <a:srgbClr val="0563C1"/>
+        <a:srgbClr val="467886"/>
       </a:hlink>
       <a:folHlink>
-        <a:srgbClr val="954F72"/>
+        <a:srgbClr val="96607D"/>
       </a:folHlink>
     </a:clrScheme>
-    <a:fontScheme name="Office 2013 - 2022 Theme">
+    <a:fontScheme name="Office">
       <a:majorFont>
-        <a:latin typeface="Calibri Light" panose="020F0302020204030204"/>
+        <a:latin typeface="Aptos Display" panose="02110004020202020204"/>
         <a:ea typeface=""/>
         <a:cs typeface=""/>
         <a:font script="Jpan" typeface="游ゴシック Light"/>
@@ -4143,9 +5835,26 @@
         <a:font script="Viet" typeface="Times New Roman"/>
         <a:font script="Uigh" typeface="Microsoft Uighur"/>
         <a:font script="Geor" typeface="Sylfaen"/>
+        <a:font script="Armn" typeface="Arial"/>
+        <a:font script="Bugi" typeface="Leelawadee UI"/>
+        <a:font script="Bopo" typeface="Microsoft JhengHei"/>
+        <a:font script="Java" typeface="Javanese Text"/>
+        <a:font script="Lisu" typeface="Segoe UI"/>
+        <a:font script="Mymr" typeface="Myanmar Text"/>
+        <a:font script="Nkoo" typeface="Ebrima"/>
+        <a:font script="Olck" typeface="Nirmala UI"/>
+        <a:font script="Osma" typeface="Ebrima"/>
+        <a:font script="Phag" typeface="Phagspa"/>
+        <a:font script="Syrn" typeface="Estrangelo Edessa"/>
+        <a:font script="Syrj" typeface="Estrangelo Edessa"/>
+        <a:font script="Syre" typeface="Estrangelo Edessa"/>
+        <a:font script="Sora" typeface="Nirmala UI"/>
+        <a:font script="Tale" typeface="Microsoft Tai Le"/>
+        <a:font script="Talu" typeface="Microsoft New Tai Lue"/>
+        <a:font script="Tfng" typeface="Ebrima"/>
       </a:majorFont>
       <a:minorFont>
-        <a:latin typeface="Calibri" panose="020F0502020204030204"/>
+        <a:latin typeface="Aptos" panose="02110004020202020204"/>
         <a:ea typeface=""/>
         <a:cs typeface=""/>
         <a:font script="Jpan" typeface="游ゴシック"/>
@@ -4178,9 +5887,26 @@
         <a:font script="Viet" typeface="Arial"/>
         <a:font script="Uigh" typeface="Microsoft Uighur"/>
         <a:font script="Geor" typeface="Sylfaen"/>
+        <a:font script="Armn" typeface="Arial"/>
+        <a:font script="Bugi" typeface="Leelawadee UI"/>
+        <a:font script="Bopo" typeface="Microsoft JhengHei"/>
+        <a:font script="Java" typeface="Javanese Text"/>
+        <a:font script="Lisu" typeface="Segoe UI"/>
+        <a:font script="Mymr" typeface="Myanmar Text"/>
+        <a:font script="Nkoo" typeface="Ebrima"/>
+        <a:font script="Olck" typeface="Nirmala UI"/>
+        <a:font script="Osma" typeface="Ebrima"/>
+        <a:font script="Phag" typeface="Phagspa"/>
+        <a:font script="Syrn" typeface="Estrangelo Edessa"/>
+        <a:font script="Syrj" typeface="Estrangelo Edessa"/>
+        <a:font script="Syre" typeface="Estrangelo Edessa"/>
+        <a:font script="Sora" typeface="Nirmala UI"/>
+        <a:font script="Tale" typeface="Microsoft Tai Le"/>
+        <a:font script="Talu" typeface="Microsoft New Tai Lue"/>
+        <a:font script="Tfng" typeface="Ebrima"/>
       </a:minorFont>
     </a:fontScheme>
-    <a:fmtScheme name="Office 2013 - 2022 Theme">
+    <a:fmtScheme name="Office">
       <a:fillStyleLst>
         <a:solidFill>
           <a:schemeClr val="phClr"/>
@@ -4239,13 +5965,6 @@
         </a:gradFill>
       </a:fillStyleLst>
       <a:lnStyleLst>
-        <a:ln w="6350" cap="flat" cmpd="sng" algn="ctr">
-          <a:solidFill>
-            <a:schemeClr val="phClr"/>
-          </a:solidFill>
-          <a:prstDash val="solid"/>
-          <a:miter lim="800000"/>
-        </a:ln>
         <a:ln w="12700" cap="flat" cmpd="sng" algn="ctr">
           <a:solidFill>
             <a:schemeClr val="phClr"/>
@@ -4254,6 +5973,13 @@
           <a:miter lim="800000"/>
         </a:ln>
         <a:ln w="19050" cap="flat" cmpd="sng" algn="ctr">
+          <a:solidFill>
+            <a:schemeClr val="phClr"/>
+          </a:solidFill>
+          <a:prstDash val="solid"/>
+          <a:miter lim="800000"/>
+        </a:ln>
+        <a:ln w="25400" cap="flat" cmpd="sng" algn="ctr">
           <a:solidFill>
             <a:schemeClr val="phClr"/>
           </a:solidFill>
@@ -4318,11 +6044,31 @@
       </a:bgFillStyleLst>
     </a:fmtScheme>
   </a:themeElements>
-  <a:objectDefaults/>
+  <a:objectDefaults>
+    <a:lnDef>
+      <a:spPr/>
+      <a:bodyPr/>
+      <a:lstStyle/>
+      <a:style>
+        <a:lnRef idx="2">
+          <a:schemeClr val="accent1"/>
+        </a:lnRef>
+        <a:fillRef idx="0">
+          <a:schemeClr val="accent1"/>
+        </a:fillRef>
+        <a:effectRef idx="1">
+          <a:schemeClr val="accent1"/>
+        </a:effectRef>
+        <a:fontRef idx="minor">
+          <a:schemeClr val="tx1"/>
+        </a:fontRef>
+      </a:style>
+    </a:lnDef>
+  </a:objectDefaults>
   <a:extraClrSchemeLst/>
   <a:extLst>
     <a:ext uri="{05A4C25C-085E-4340-85A3-A5531E510DB2}">
-      <thm15:themeFamily xmlns:thm15="http://schemas.microsoft.com/office/thememl/2012/main" name="Office 2013 - 2022 Theme" id="{62F939B6-93AF-4DB8-9C6B-D6C7DFDC589F}" vid="{4A3C46E8-61CC-4603-A589-7422A47A8E4A}"/>
+      <thm15:themeFamily xmlns:thm15="http://schemas.microsoft.com/office/thememl/2012/main" name="Office Theme" id="{2E142A2C-CD16-42D6-873A-C26D2A0506FA}" vid="{1BDDFF52-6CD6-40A5-AB3C-68EB2F1E4D0A}"/>
     </a:ext>
   </a:extLst>
 </a:theme>

</xml_diff>